<commit_message>
Resync presentation with the report's new 4-chapter structure
Sommaire and section kickers now match: Contexte général,
Analyse des besoins et conception, Architecture technique et
technologies, Mise en œuvre et captures d'écran, Bilan et
perspectives. Also added a dedicated sequence-diagram slide
(previously only use case + MCD were covered) for full UML parity
with the report's chapter 2.

Co-Authored-By: Claude Sonnet 5 <noreply@anthropic.com>
Claude-Session: https://claude.ai/code/session_01N71ZQ4J4DjQK6Dw7fWYZN9
</commit_message>
<xml_diff>
--- a/rapport/NetSentry_Presentation.pptx
+++ b/rapport/NetSentry_Presentation.pptx
@@ -26,6 +26,7 @@
     <p:sldId id="274" r:id="rId25"/>
     <p:sldId id="275" r:id="rId26"/>
     <p:sldId id="276" r:id="rId27"/>
+    <p:sldId id="277" r:id="rId28"/>
   </p:sldIdLst>
   <p:sldSz cx="12191695" cy="6858000" type="screen4x3"/>
   <p:notesSz cx="6858000" cy="9144000"/>
@@ -3542,7 +3543,7 @@
         <p:spPr>
           <a:xfrm>
             <a:off x="502920" y="73152"/>
-            <a:ext cx="7315200" cy="320040"/>
+            <a:ext cx="9144000" cy="320040"/>
           </a:xfrm>
           <a:prstGeom prst="rect">
             <a:avLst/>
@@ -3567,7 +3568,7 @@
                 </a:solidFill>
                 <a:latin typeface="Calibri"/>
               </a:rPr>
-              <a:t>6. NMAP : LE MOTEUR DE DÉCOUVERTE</a:t>
+              <a:t>3. ARCHITECTURE TECHNIQUE ET TECHNOLOGIES</a:t>
             </a:r>
           </a:p>
         </p:txBody>
@@ -3606,7 +3607,7 @@
                 </a:solidFill>
                 <a:latin typeface="Georgia"/>
               </a:rPr>
-              <a:t>Nmap : le moteur de découverte</a:t>
+              <a:t>Architecture générale</a:t>
             </a:r>
           </a:p>
         </p:txBody>
@@ -3657,7 +3658,7 @@
       </p:sp>
       <p:pic>
         <p:nvPicPr>
-          <p:cNvPr id="6" name="Picture 5" descr="nmap.png"/>
+          <p:cNvPr id="6" name="Picture 5" descr="architecture.png"/>
           <p:cNvPicPr>
             <a:picLocks noChangeAspect="1"/>
           </p:cNvPicPr>
@@ -3671,8 +3672,8 @@
         </p:blipFill>
         <p:spPr>
           <a:xfrm>
-            <a:off x="9326880" y="1423851"/>
-            <a:ext cx="2194560" cy="1175657"/>
+            <a:off x="2423731" y="1371600"/>
+            <a:ext cx="7314057" cy="4937760"/>
           </a:xfrm>
           <a:prstGeom prst="rect">
             <a:avLst/>
@@ -3682,163 +3683,6 @@
       <p:sp>
         <p:nvSpPr>
           <p:cNvPr id="7" name="TextBox 6"/>
-          <p:cNvSpPr txBox="1"/>
-          <p:nvPr/>
-        </p:nvSpPr>
-        <p:spPr>
-          <a:xfrm>
-            <a:off x="548640" y="1463040"/>
-            <a:ext cx="8412480" cy="4754880"/>
-          </a:xfrm>
-          <a:prstGeom prst="rect">
-            <a:avLst/>
-          </a:prstGeom>
-          <a:noFill/>
-        </p:spPr>
-        <p:txBody>
-          <a:bodyPr wrap="square">
-            <a:spAutoFit/>
-          </a:bodyPr>
-          <a:lstStyle/>
-          <a:p>
-            <a:pPr>
-              <a:lnSpc>
-                <a:spcPct val="108000"/>
-              </a:lnSpc>
-              <a:spcAft>
-                <a:spcPts val="1400"/>
-              </a:spcAft>
-            </a:pPr>
-            <a:r>
-              <a:rPr sz="1550">
-                <a:solidFill>
-                  <a:srgbClr val="222222"/>
-                </a:solidFill>
-                <a:latin typeface="Calibri"/>
-              </a:rPr>
-              <a:t>•  Scanner réseau open source (Gordon Lyon, 1997)</a:t>
-            </a:r>
-          </a:p>
-          <a:p>
-            <a:pPr>
-              <a:lnSpc>
-                <a:spcPct val="108000"/>
-              </a:lnSpc>
-              <a:spcAft>
-                <a:spcPts val="1400"/>
-              </a:spcAft>
-            </a:pPr>
-            <a:r>
-              <a:rPr sz="1550">
-                <a:solidFill>
-                  <a:srgbClr val="222222"/>
-                </a:solidFill>
-                <a:latin typeface="Calibri"/>
-              </a:rPr>
-              <a:t>•  Phase 1 — Découverte : nmap -sn &lt;CIDR&gt;</a:t>
-            </a:r>
-            <a:br/>
-            <a:r>
-              <a:rPr sz="1550">
-                <a:solidFill>
-                  <a:srgbClr val="222222"/>
-                </a:solidFill>
-                <a:latin typeface="Calibri"/>
-              </a:rPr>
-              <a:t>ARP broadcast : rapide, fournit l'adresse MAC gratuitement</a:t>
-            </a:r>
-          </a:p>
-          <a:p>
-            <a:pPr>
-              <a:lnSpc>
-                <a:spcPct val="108000"/>
-              </a:lnSpc>
-              <a:spcAft>
-                <a:spcPts val="1400"/>
-              </a:spcAft>
-            </a:pPr>
-            <a:r>
-              <a:rPr sz="1550">
-                <a:solidFill>
-                  <a:srgbClr val="222222"/>
-                </a:solidFill>
-                <a:latin typeface="Calibri"/>
-              </a:rPr>
-              <a:t>•  Phase 2 — Enrichissement : nmap -sV --top-ports 100</a:t>
-            </a:r>
-            <a:br/>
-            <a:r>
-              <a:rPr sz="1550">
-                <a:solidFill>
-                  <a:srgbClr val="222222"/>
-                </a:solidFill>
-                <a:latin typeface="Calibri"/>
-              </a:rPr>
-              <a:t>limité aux hôtes découverts (performance)</a:t>
-            </a:r>
-          </a:p>
-          <a:p>
-            <a:pPr>
-              <a:lnSpc>
-                <a:spcPct val="108000"/>
-              </a:lnSpc>
-              <a:spcAft>
-                <a:spcPts val="1400"/>
-              </a:spcAft>
-            </a:pPr>
-            <a:r>
-              <a:rPr sz="1550">
-                <a:solidFill>
-                  <a:srgbClr val="222222"/>
-                </a:solidFill>
-                <a:latin typeface="Calibri"/>
-              </a:rPr>
-              <a:t>•  Identification du fabricant via une base OUI locale (aucune donnée envoyée à l'extérieur)</a:t>
-            </a:r>
-          </a:p>
-          <a:p>
-            <a:pPr>
-              <a:lnSpc>
-                <a:spcPct val="108000"/>
-              </a:lnSpc>
-              <a:spcAft>
-                <a:spcPts val="1400"/>
-              </a:spcAft>
-            </a:pPr>
-            <a:r>
-              <a:rPr sz="1550">
-                <a:solidFill>
-                  <a:srgbClr val="222222"/>
-                </a:solidFill>
-                <a:latin typeface="Calibri"/>
-              </a:rPr>
-              <a:t>•  Adresses MAC aléatoires (iOS/Android) → fabricant "inconnu" par conception, pas par échec</a:t>
-            </a:r>
-          </a:p>
-          <a:p>
-            <a:pPr>
-              <a:lnSpc>
-                <a:spcPct val="108000"/>
-              </a:lnSpc>
-              <a:spcAft>
-                <a:spcPts val="1400"/>
-              </a:spcAft>
-            </a:pPr>
-            <a:r>
-              <a:rPr sz="1550">
-                <a:solidFill>
-                  <a:srgbClr val="222222"/>
-                </a:solidFill>
-                <a:latin typeface="Calibri"/>
-              </a:rPr>
-              <a:t>•  nmap -O (détection d'OS) volontairement hors périmètre : privilèges supplémentaires, fiabilité variable</a:t>
-            </a:r>
-          </a:p>
-        </p:txBody>
-      </p:sp>
-      <p:sp>
-        <p:nvSpPr>
-          <p:cNvPr id="8" name="TextBox 7"/>
           <p:cNvSpPr txBox="1"/>
           <p:nvPr/>
         </p:nvSpPr>
@@ -3877,7 +3721,7 @@
       </p:sp>
       <p:sp>
         <p:nvSpPr>
-          <p:cNvPr id="9" name="TextBox 8"/>
+          <p:cNvPr id="8" name="TextBox 7"/>
           <p:cNvSpPr txBox="1"/>
           <p:nvPr/>
         </p:nvSpPr>
@@ -3993,7 +3837,7 @@
         <p:spPr>
           <a:xfrm>
             <a:off x="502920" y="73152"/>
-            <a:ext cx="7315200" cy="320040"/>
+            <a:ext cx="9144000" cy="320040"/>
           </a:xfrm>
           <a:prstGeom prst="rect">
             <a:avLst/>
@@ -4018,7 +3862,7 @@
                 </a:solidFill>
                 <a:latin typeface="Calibri"/>
               </a:rPr>
-              <a:t>5. ARCHITECTURE TECHNIQUE ET TECHNOLOGIES</a:t>
+              <a:t>3. ARCHITECTURE TECHNIQUE ET TECHNOLOGIES</a:t>
             </a:r>
           </a:p>
         </p:txBody>
@@ -4057,7 +3901,7 @@
                 </a:solidFill>
                 <a:latin typeface="Georgia"/>
               </a:rPr>
-              <a:t>Technologies utilisées</a:t>
+              <a:t>Nmap : le moteur de découverte</a:t>
             </a:r>
           </a:p>
         </p:txBody>
@@ -4106,53 +3950,9 @@
           </a:p>
         </p:txBody>
       </p:sp>
-      <p:sp>
-        <p:nvSpPr>
-          <p:cNvPr id="6" name="Rectangle 5"/>
-          <p:cNvSpPr/>
-          <p:nvPr/>
-        </p:nvSpPr>
-        <p:spPr>
-          <a:xfrm>
-            <a:off x="685800" y="1920240"/>
-            <a:ext cx="1783080" cy="2011680"/>
-          </a:xfrm>
-          <a:prstGeom prst="rect">
-            <a:avLst/>
-          </a:prstGeom>
-          <a:solidFill>
-            <a:srgbClr val="EFF3E9"/>
-          </a:solidFill>
-          <a:ln>
-            <a:noFill/>
-          </a:ln>
-          <a:effectLst/>
-        </p:spPr>
-        <p:style>
-          <a:lnRef idx="1">
-            <a:schemeClr val="accent1"/>
-          </a:lnRef>
-          <a:fillRef idx="3">
-            <a:schemeClr val="accent1"/>
-          </a:fillRef>
-          <a:effectRef idx="2">
-            <a:schemeClr val="accent1"/>
-          </a:effectRef>
-          <a:fontRef idx="minor">
-            <a:schemeClr val="lt1"/>
-          </a:fontRef>
-        </p:style>
-        <p:txBody>
-          <a:bodyPr rtlCol="0" anchor="ctr"/>
-          <a:lstStyle/>
-          <a:p>
-            <a:pPr algn="ctr"/>
-          </a:p>
-        </p:txBody>
-      </p:sp>
       <p:pic>
         <p:nvPicPr>
-          <p:cNvPr id="7" name="Picture 6" descr="nodejs.png"/>
+          <p:cNvPr id="6" name="Picture 5" descr="nmap.png"/>
           <p:cNvPicPr>
             <a:picLocks noChangeAspect="1"/>
           </p:cNvPicPr>
@@ -4166,14 +3966,171 @@
         </p:blipFill>
         <p:spPr>
           <a:xfrm>
-            <a:off x="822960" y="2235422"/>
-            <a:ext cx="1508760" cy="924115"/>
+            <a:off x="9326880" y="1423851"/>
+            <a:ext cx="2194560" cy="1175657"/>
           </a:xfrm>
           <a:prstGeom prst="rect">
             <a:avLst/>
           </a:prstGeom>
         </p:spPr>
       </p:pic>
+      <p:sp>
+        <p:nvSpPr>
+          <p:cNvPr id="7" name="TextBox 6"/>
+          <p:cNvSpPr txBox="1"/>
+          <p:nvPr/>
+        </p:nvSpPr>
+        <p:spPr>
+          <a:xfrm>
+            <a:off x="548640" y="1463040"/>
+            <a:ext cx="8412480" cy="4754880"/>
+          </a:xfrm>
+          <a:prstGeom prst="rect">
+            <a:avLst/>
+          </a:prstGeom>
+          <a:noFill/>
+        </p:spPr>
+        <p:txBody>
+          <a:bodyPr wrap="square">
+            <a:spAutoFit/>
+          </a:bodyPr>
+          <a:lstStyle/>
+          <a:p>
+            <a:pPr>
+              <a:lnSpc>
+                <a:spcPct val="108000"/>
+              </a:lnSpc>
+              <a:spcAft>
+                <a:spcPts val="1400"/>
+              </a:spcAft>
+            </a:pPr>
+            <a:r>
+              <a:rPr sz="1550">
+                <a:solidFill>
+                  <a:srgbClr val="222222"/>
+                </a:solidFill>
+                <a:latin typeface="Calibri"/>
+              </a:rPr>
+              <a:t>•  Scanner réseau open source (Gordon Lyon, 1997)</a:t>
+            </a:r>
+          </a:p>
+          <a:p>
+            <a:pPr>
+              <a:lnSpc>
+                <a:spcPct val="108000"/>
+              </a:lnSpc>
+              <a:spcAft>
+                <a:spcPts val="1400"/>
+              </a:spcAft>
+            </a:pPr>
+            <a:r>
+              <a:rPr sz="1550">
+                <a:solidFill>
+                  <a:srgbClr val="222222"/>
+                </a:solidFill>
+                <a:latin typeface="Calibri"/>
+              </a:rPr>
+              <a:t>•  Phase 1 — Découverte : nmap -sn &lt;CIDR&gt;</a:t>
+            </a:r>
+            <a:br/>
+            <a:r>
+              <a:rPr sz="1550">
+                <a:solidFill>
+                  <a:srgbClr val="222222"/>
+                </a:solidFill>
+                <a:latin typeface="Calibri"/>
+              </a:rPr>
+              <a:t>ARP broadcast : rapide, fournit l'adresse MAC gratuitement</a:t>
+            </a:r>
+          </a:p>
+          <a:p>
+            <a:pPr>
+              <a:lnSpc>
+                <a:spcPct val="108000"/>
+              </a:lnSpc>
+              <a:spcAft>
+                <a:spcPts val="1400"/>
+              </a:spcAft>
+            </a:pPr>
+            <a:r>
+              <a:rPr sz="1550">
+                <a:solidFill>
+                  <a:srgbClr val="222222"/>
+                </a:solidFill>
+                <a:latin typeface="Calibri"/>
+              </a:rPr>
+              <a:t>•  Phase 2 — Enrichissement : nmap -sV --top-ports 100</a:t>
+            </a:r>
+            <a:br/>
+            <a:r>
+              <a:rPr sz="1550">
+                <a:solidFill>
+                  <a:srgbClr val="222222"/>
+                </a:solidFill>
+                <a:latin typeface="Calibri"/>
+              </a:rPr>
+              <a:t>limité aux hôtes découverts (performance)</a:t>
+            </a:r>
+          </a:p>
+          <a:p>
+            <a:pPr>
+              <a:lnSpc>
+                <a:spcPct val="108000"/>
+              </a:lnSpc>
+              <a:spcAft>
+                <a:spcPts val="1400"/>
+              </a:spcAft>
+            </a:pPr>
+            <a:r>
+              <a:rPr sz="1550">
+                <a:solidFill>
+                  <a:srgbClr val="222222"/>
+                </a:solidFill>
+                <a:latin typeface="Calibri"/>
+              </a:rPr>
+              <a:t>•  Identification du fabricant via une base OUI locale (aucune donnée envoyée à l'extérieur)</a:t>
+            </a:r>
+          </a:p>
+          <a:p>
+            <a:pPr>
+              <a:lnSpc>
+                <a:spcPct val="108000"/>
+              </a:lnSpc>
+              <a:spcAft>
+                <a:spcPts val="1400"/>
+              </a:spcAft>
+            </a:pPr>
+            <a:r>
+              <a:rPr sz="1550">
+                <a:solidFill>
+                  <a:srgbClr val="222222"/>
+                </a:solidFill>
+                <a:latin typeface="Calibri"/>
+              </a:rPr>
+              <a:t>•  Adresses MAC aléatoires (iOS/Android) → fabricant "inconnu" par conception, pas par échec</a:t>
+            </a:r>
+          </a:p>
+          <a:p>
+            <a:pPr>
+              <a:lnSpc>
+                <a:spcPct val="108000"/>
+              </a:lnSpc>
+              <a:spcAft>
+                <a:spcPts val="1400"/>
+              </a:spcAft>
+            </a:pPr>
+            <a:r>
+              <a:rPr sz="1550">
+                <a:solidFill>
+                  <a:srgbClr val="222222"/>
+                </a:solidFill>
+                <a:latin typeface="Calibri"/>
+              </a:rPr>
+              <a:t>•  nmap -O (détection d'OS) volontairement hors périmètre : privilèges supplémentaires, fiabilité variable</a:t>
+            </a:r>
+          </a:p>
+        </p:txBody>
+      </p:sp>
       <p:sp>
         <p:nvSpPr>
           <p:cNvPr id="8" name="TextBox 7"/>
@@ -4182,8 +4139,8 @@
         </p:nvSpPr>
         <p:spPr>
           <a:xfrm>
-            <a:off x="685800" y="3429000"/>
-            <a:ext cx="1783080" cy="365760"/>
+            <a:off x="502920" y="6473952"/>
+            <a:ext cx="5486400" cy="320040"/>
           </a:xfrm>
           <a:prstGeom prst="rect">
             <a:avLst/>
@@ -4196,685 +4153,12 @@
           </a:bodyPr>
           <a:lstStyle/>
           <a:p>
-            <a:pPr algn="ctr">
+            <a:pPr algn="l">
               <a:lnSpc>
                 <a:spcPct val="100000"/>
               </a:lnSpc>
             </a:pPr>
             <a:r>
-              <a:rPr sz="1300" b="1" i="0">
-                <a:solidFill>
-                  <a:srgbClr val="3A491E"/>
-                </a:solidFill>
-                <a:latin typeface="Calibri"/>
-              </a:rPr>
-              <a:t>Node.js</a:t>
-            </a:r>
-          </a:p>
-        </p:txBody>
-      </p:sp>
-      <p:sp>
-        <p:nvSpPr>
-          <p:cNvPr id="9" name="Rectangle 8"/>
-          <p:cNvSpPr/>
-          <p:nvPr/>
-        </p:nvSpPr>
-        <p:spPr>
-          <a:xfrm>
-            <a:off x="2606040" y="1920240"/>
-            <a:ext cx="1783080" cy="2011680"/>
-          </a:xfrm>
-          <a:prstGeom prst="rect">
-            <a:avLst/>
-          </a:prstGeom>
-          <a:solidFill>
-            <a:srgbClr val="EFF3E9"/>
-          </a:solidFill>
-          <a:ln>
-            <a:noFill/>
-          </a:ln>
-          <a:effectLst/>
-        </p:spPr>
-        <p:style>
-          <a:lnRef idx="1">
-            <a:schemeClr val="accent1"/>
-          </a:lnRef>
-          <a:fillRef idx="3">
-            <a:schemeClr val="accent1"/>
-          </a:fillRef>
-          <a:effectRef idx="2">
-            <a:schemeClr val="accent1"/>
-          </a:effectRef>
-          <a:fontRef idx="minor">
-            <a:schemeClr val="lt1"/>
-          </a:fontRef>
-        </p:style>
-        <p:txBody>
-          <a:bodyPr rtlCol="0" anchor="ctr"/>
-          <a:lstStyle/>
-          <a:p>
-            <a:pPr algn="ctr"/>
-          </a:p>
-        </p:txBody>
-      </p:sp>
-      <p:pic>
-        <p:nvPicPr>
-          <p:cNvPr id="10" name="Picture 9" descr="express.png"/>
-          <p:cNvPicPr>
-            <a:picLocks noChangeAspect="1"/>
-          </p:cNvPicPr>
-          <p:nvPr/>
-        </p:nvPicPr>
-        <p:blipFill>
-          <a:blip r:embed="rId3"/>
-          <a:stretch>
-            <a:fillRect/>
-          </a:stretch>
-        </p:blipFill>
-        <p:spPr>
-          <a:xfrm>
-            <a:off x="2743200" y="2468732"/>
-            <a:ext cx="1508760" cy="457494"/>
-          </a:xfrm>
-          <a:prstGeom prst="rect">
-            <a:avLst/>
-          </a:prstGeom>
-        </p:spPr>
-      </p:pic>
-      <p:sp>
-        <p:nvSpPr>
-          <p:cNvPr id="11" name="TextBox 10"/>
-          <p:cNvSpPr txBox="1"/>
-          <p:nvPr/>
-        </p:nvSpPr>
-        <p:spPr>
-          <a:xfrm>
-            <a:off x="2606040" y="3429000"/>
-            <a:ext cx="1783080" cy="365760"/>
-          </a:xfrm>
-          <a:prstGeom prst="rect">
-            <a:avLst/>
-          </a:prstGeom>
-          <a:noFill/>
-        </p:spPr>
-        <p:txBody>
-          <a:bodyPr wrap="square" anchor="t">
-            <a:spAutoFit/>
-          </a:bodyPr>
-          <a:lstStyle/>
-          <a:p>
-            <a:pPr algn="ctr">
-              <a:lnSpc>
-                <a:spcPct val="100000"/>
-              </a:lnSpc>
-            </a:pPr>
-            <a:r>
-              <a:rPr sz="1300" b="1" i="0">
-                <a:solidFill>
-                  <a:srgbClr val="3A491E"/>
-                </a:solidFill>
-                <a:latin typeface="Calibri"/>
-              </a:rPr>
-              <a:t>Express</a:t>
-            </a:r>
-          </a:p>
-        </p:txBody>
-      </p:sp>
-      <p:sp>
-        <p:nvSpPr>
-          <p:cNvPr id="12" name="Rectangle 11"/>
-          <p:cNvSpPr/>
-          <p:nvPr/>
-        </p:nvSpPr>
-        <p:spPr>
-          <a:xfrm>
-            <a:off x="4526280" y="1920240"/>
-            <a:ext cx="1783080" cy="2011680"/>
-          </a:xfrm>
-          <a:prstGeom prst="rect">
-            <a:avLst/>
-          </a:prstGeom>
-          <a:solidFill>
-            <a:srgbClr val="EFF3E9"/>
-          </a:solidFill>
-          <a:ln>
-            <a:noFill/>
-          </a:ln>
-          <a:effectLst/>
-        </p:spPr>
-        <p:style>
-          <a:lnRef idx="1">
-            <a:schemeClr val="accent1"/>
-          </a:lnRef>
-          <a:fillRef idx="3">
-            <a:schemeClr val="accent1"/>
-          </a:fillRef>
-          <a:effectRef idx="2">
-            <a:schemeClr val="accent1"/>
-          </a:effectRef>
-          <a:fontRef idx="minor">
-            <a:schemeClr val="lt1"/>
-          </a:fontRef>
-        </p:style>
-        <p:txBody>
-          <a:bodyPr rtlCol="0" anchor="ctr"/>
-          <a:lstStyle/>
-          <a:p>
-            <a:pPr algn="ctr"/>
-          </a:p>
-        </p:txBody>
-      </p:sp>
-      <p:pic>
-        <p:nvPicPr>
-          <p:cNvPr id="13" name="Picture 12" descr="postgresql.png"/>
-          <p:cNvPicPr>
-            <a:picLocks noChangeAspect="1"/>
-          </p:cNvPicPr>
-          <p:nvPr/>
-        </p:nvPicPr>
-        <p:blipFill>
-          <a:blip r:embed="rId4"/>
-          <a:stretch>
-            <a:fillRect/>
-          </a:stretch>
-        </p:blipFill>
-        <p:spPr>
-          <a:xfrm>
-            <a:off x="4841470" y="2103120"/>
-            <a:ext cx="1152698" cy="1188720"/>
-          </a:xfrm>
-          <a:prstGeom prst="rect">
-            <a:avLst/>
-          </a:prstGeom>
-        </p:spPr>
-      </p:pic>
-      <p:sp>
-        <p:nvSpPr>
-          <p:cNvPr id="14" name="TextBox 13"/>
-          <p:cNvSpPr txBox="1"/>
-          <p:nvPr/>
-        </p:nvSpPr>
-        <p:spPr>
-          <a:xfrm>
-            <a:off x="4526280" y="3429000"/>
-            <a:ext cx="1783080" cy="365760"/>
-          </a:xfrm>
-          <a:prstGeom prst="rect">
-            <a:avLst/>
-          </a:prstGeom>
-          <a:noFill/>
-        </p:spPr>
-        <p:txBody>
-          <a:bodyPr wrap="square" anchor="t">
-            <a:spAutoFit/>
-          </a:bodyPr>
-          <a:lstStyle/>
-          <a:p>
-            <a:pPr algn="ctr">
-              <a:lnSpc>
-                <a:spcPct val="100000"/>
-              </a:lnSpc>
-            </a:pPr>
-            <a:r>
-              <a:rPr sz="1300" b="1" i="0">
-                <a:solidFill>
-                  <a:srgbClr val="3A491E"/>
-                </a:solidFill>
-                <a:latin typeface="Calibri"/>
-              </a:rPr>
-              <a:t>PostgreSQL</a:t>
-            </a:r>
-          </a:p>
-        </p:txBody>
-      </p:sp>
-      <p:sp>
-        <p:nvSpPr>
-          <p:cNvPr id="15" name="Rectangle 14"/>
-          <p:cNvSpPr/>
-          <p:nvPr/>
-        </p:nvSpPr>
-        <p:spPr>
-          <a:xfrm>
-            <a:off x="6446520" y="1920240"/>
-            <a:ext cx="1783080" cy="2011680"/>
-          </a:xfrm>
-          <a:prstGeom prst="rect">
-            <a:avLst/>
-          </a:prstGeom>
-          <a:solidFill>
-            <a:srgbClr val="EFF3E9"/>
-          </a:solidFill>
-          <a:ln>
-            <a:noFill/>
-          </a:ln>
-          <a:effectLst/>
-        </p:spPr>
-        <p:style>
-          <a:lnRef idx="1">
-            <a:schemeClr val="accent1"/>
-          </a:lnRef>
-          <a:fillRef idx="3">
-            <a:schemeClr val="accent1"/>
-          </a:fillRef>
-          <a:effectRef idx="2">
-            <a:schemeClr val="accent1"/>
-          </a:effectRef>
-          <a:fontRef idx="minor">
-            <a:schemeClr val="lt1"/>
-          </a:fontRef>
-        </p:style>
-        <p:txBody>
-          <a:bodyPr rtlCol="0" anchor="ctr"/>
-          <a:lstStyle/>
-          <a:p>
-            <a:pPr algn="ctr"/>
-          </a:p>
-        </p:txBody>
-      </p:sp>
-      <p:pic>
-        <p:nvPicPr>
-          <p:cNvPr id="16" name="Picture 15" descr="react.png"/>
-          <p:cNvPicPr>
-            <a:picLocks noChangeAspect="1"/>
-          </p:cNvPicPr>
-          <p:nvPr/>
-        </p:nvPicPr>
-        <p:blipFill>
-          <a:blip r:embed="rId5"/>
-          <a:stretch>
-            <a:fillRect/>
-          </a:stretch>
-        </p:blipFill>
-        <p:spPr>
-          <a:xfrm>
-            <a:off x="6692893" y="2103120"/>
-            <a:ext cx="1290333" cy="1188720"/>
-          </a:xfrm>
-          <a:prstGeom prst="rect">
-            <a:avLst/>
-          </a:prstGeom>
-        </p:spPr>
-      </p:pic>
-      <p:sp>
-        <p:nvSpPr>
-          <p:cNvPr id="17" name="TextBox 16"/>
-          <p:cNvSpPr txBox="1"/>
-          <p:nvPr/>
-        </p:nvSpPr>
-        <p:spPr>
-          <a:xfrm>
-            <a:off x="6446520" y="3429000"/>
-            <a:ext cx="1783080" cy="365760"/>
-          </a:xfrm>
-          <a:prstGeom prst="rect">
-            <a:avLst/>
-          </a:prstGeom>
-          <a:noFill/>
-        </p:spPr>
-        <p:txBody>
-          <a:bodyPr wrap="square" anchor="t">
-            <a:spAutoFit/>
-          </a:bodyPr>
-          <a:lstStyle/>
-          <a:p>
-            <a:pPr algn="ctr">
-              <a:lnSpc>
-                <a:spcPct val="100000"/>
-              </a:lnSpc>
-            </a:pPr>
-            <a:r>
-              <a:rPr sz="1300" b="1" i="0">
-                <a:solidFill>
-                  <a:srgbClr val="3A491E"/>
-                </a:solidFill>
-                <a:latin typeface="Calibri"/>
-              </a:rPr>
-              <a:t>React</a:t>
-            </a:r>
-          </a:p>
-        </p:txBody>
-      </p:sp>
-      <p:sp>
-        <p:nvSpPr>
-          <p:cNvPr id="18" name="Rectangle 17"/>
-          <p:cNvSpPr/>
-          <p:nvPr/>
-        </p:nvSpPr>
-        <p:spPr>
-          <a:xfrm>
-            <a:off x="8366760" y="1920240"/>
-            <a:ext cx="1783080" cy="2011680"/>
-          </a:xfrm>
-          <a:prstGeom prst="rect">
-            <a:avLst/>
-          </a:prstGeom>
-          <a:solidFill>
-            <a:srgbClr val="EFF3E9"/>
-          </a:solidFill>
-          <a:ln>
-            <a:noFill/>
-          </a:ln>
-          <a:effectLst/>
-        </p:spPr>
-        <p:style>
-          <a:lnRef idx="1">
-            <a:schemeClr val="accent1"/>
-          </a:lnRef>
-          <a:fillRef idx="3">
-            <a:schemeClr val="accent1"/>
-          </a:fillRef>
-          <a:effectRef idx="2">
-            <a:schemeClr val="accent1"/>
-          </a:effectRef>
-          <a:fontRef idx="minor">
-            <a:schemeClr val="lt1"/>
-          </a:fontRef>
-        </p:style>
-        <p:txBody>
-          <a:bodyPr rtlCol="0" anchor="ctr"/>
-          <a:lstStyle/>
-          <a:p>
-            <a:pPr algn="ctr"/>
-          </a:p>
-        </p:txBody>
-      </p:sp>
-      <p:pic>
-        <p:nvPicPr>
-          <p:cNvPr id="19" name="Picture 18" descr="docker.png"/>
-          <p:cNvPicPr>
-            <a:picLocks noChangeAspect="1"/>
-          </p:cNvPicPr>
-          <p:nvPr/>
-        </p:nvPicPr>
-        <p:blipFill>
-          <a:blip r:embed="rId6"/>
-          <a:stretch>
-            <a:fillRect/>
-          </a:stretch>
-        </p:blipFill>
-        <p:spPr>
-          <a:xfrm>
-            <a:off x="8503920" y="2525858"/>
-            <a:ext cx="1508760" cy="343242"/>
-          </a:xfrm>
-          <a:prstGeom prst="rect">
-            <a:avLst/>
-          </a:prstGeom>
-        </p:spPr>
-      </p:pic>
-      <p:sp>
-        <p:nvSpPr>
-          <p:cNvPr id="20" name="TextBox 19"/>
-          <p:cNvSpPr txBox="1"/>
-          <p:nvPr/>
-        </p:nvSpPr>
-        <p:spPr>
-          <a:xfrm>
-            <a:off x="8366760" y="3429000"/>
-            <a:ext cx="1783080" cy="365760"/>
-          </a:xfrm>
-          <a:prstGeom prst="rect">
-            <a:avLst/>
-          </a:prstGeom>
-          <a:noFill/>
-        </p:spPr>
-        <p:txBody>
-          <a:bodyPr wrap="square" anchor="t">
-            <a:spAutoFit/>
-          </a:bodyPr>
-          <a:lstStyle/>
-          <a:p>
-            <a:pPr algn="ctr">
-              <a:lnSpc>
-                <a:spcPct val="100000"/>
-              </a:lnSpc>
-            </a:pPr>
-            <a:r>
-              <a:rPr sz="1300" b="1" i="0">
-                <a:solidFill>
-                  <a:srgbClr val="3A491E"/>
-                </a:solidFill>
-                <a:latin typeface="Calibri"/>
-              </a:rPr>
-              <a:t>Docker</a:t>
-            </a:r>
-          </a:p>
-        </p:txBody>
-      </p:sp>
-      <p:sp>
-        <p:nvSpPr>
-          <p:cNvPr id="21" name="Rectangle 20"/>
-          <p:cNvSpPr/>
-          <p:nvPr/>
-        </p:nvSpPr>
-        <p:spPr>
-          <a:xfrm>
-            <a:off x="10287000" y="1920240"/>
-            <a:ext cx="1783080" cy="2011680"/>
-          </a:xfrm>
-          <a:prstGeom prst="rect">
-            <a:avLst/>
-          </a:prstGeom>
-          <a:solidFill>
-            <a:srgbClr val="EFF3E9"/>
-          </a:solidFill>
-          <a:ln>
-            <a:noFill/>
-          </a:ln>
-          <a:effectLst/>
-        </p:spPr>
-        <p:style>
-          <a:lnRef idx="1">
-            <a:schemeClr val="accent1"/>
-          </a:lnRef>
-          <a:fillRef idx="3">
-            <a:schemeClr val="accent1"/>
-          </a:fillRef>
-          <a:effectRef idx="2">
-            <a:schemeClr val="accent1"/>
-          </a:effectRef>
-          <a:fontRef idx="minor">
-            <a:schemeClr val="lt1"/>
-          </a:fontRef>
-        </p:style>
-        <p:txBody>
-          <a:bodyPr rtlCol="0" anchor="ctr"/>
-          <a:lstStyle/>
-          <a:p>
-            <a:pPr algn="ctr"/>
-          </a:p>
-        </p:txBody>
-      </p:sp>
-      <p:pic>
-        <p:nvPicPr>
-          <p:cNvPr id="22" name="Picture 21" descr="git.png"/>
-          <p:cNvPicPr>
-            <a:picLocks noChangeAspect="1"/>
-          </p:cNvPicPr>
-          <p:nvPr/>
-        </p:nvPicPr>
-        <p:blipFill>
-          <a:blip r:embed="rId7"/>
-          <a:stretch>
-            <a:fillRect/>
-          </a:stretch>
-        </p:blipFill>
-        <p:spPr>
-          <a:xfrm>
-            <a:off x="10424160" y="2382526"/>
-            <a:ext cx="1508760" cy="629907"/>
-          </a:xfrm>
-          <a:prstGeom prst="rect">
-            <a:avLst/>
-          </a:prstGeom>
-        </p:spPr>
-      </p:pic>
-      <p:sp>
-        <p:nvSpPr>
-          <p:cNvPr id="23" name="TextBox 22"/>
-          <p:cNvSpPr txBox="1"/>
-          <p:nvPr/>
-        </p:nvSpPr>
-        <p:spPr>
-          <a:xfrm>
-            <a:off x="10287000" y="3429000"/>
-            <a:ext cx="1783080" cy="365760"/>
-          </a:xfrm>
-          <a:prstGeom prst="rect">
-            <a:avLst/>
-          </a:prstGeom>
-          <a:noFill/>
-        </p:spPr>
-        <p:txBody>
-          <a:bodyPr wrap="square" anchor="t">
-            <a:spAutoFit/>
-          </a:bodyPr>
-          <a:lstStyle/>
-          <a:p>
-            <a:pPr algn="ctr">
-              <a:lnSpc>
-                <a:spcPct val="100000"/>
-              </a:lnSpc>
-            </a:pPr>
-            <a:r>
-              <a:rPr sz="1300" b="1" i="0">
-                <a:solidFill>
-                  <a:srgbClr val="3A491E"/>
-                </a:solidFill>
-                <a:latin typeface="Calibri"/>
-              </a:rPr>
-              <a:t>Git</a:t>
-            </a:r>
-          </a:p>
-        </p:txBody>
-      </p:sp>
-      <p:sp>
-        <p:nvSpPr>
-          <p:cNvPr id="24" name="TextBox 23"/>
-          <p:cNvSpPr txBox="1"/>
-          <p:nvPr/>
-        </p:nvSpPr>
-        <p:spPr>
-          <a:xfrm>
-            <a:off x="685800" y="4389120"/>
-            <a:ext cx="10789920" cy="1828800"/>
-          </a:xfrm>
-          <a:prstGeom prst="rect">
-            <a:avLst/>
-          </a:prstGeom>
-          <a:noFill/>
-        </p:spPr>
-        <p:txBody>
-          <a:bodyPr wrap="square">
-            <a:spAutoFit/>
-          </a:bodyPr>
-          <a:lstStyle/>
-          <a:p>
-            <a:pPr>
-              <a:lnSpc>
-                <a:spcPct val="108000"/>
-              </a:lnSpc>
-              <a:spcAft>
-                <a:spcPts val="800"/>
-              </a:spcAft>
-            </a:pPr>
-            <a:r>
-              <a:rPr sz="1450">
-                <a:solidFill>
-                  <a:srgbClr val="222222"/>
-                </a:solidFill>
-                <a:latin typeface="Calibri"/>
-              </a:rPr>
-              <a:t>•  Backend : Node.js / Express (API REST, orchestration, JWT)</a:t>
-            </a:r>
-          </a:p>
-          <a:p>
-            <a:pPr>
-              <a:lnSpc>
-                <a:spcPct val="108000"/>
-              </a:lnSpc>
-              <a:spcAft>
-                <a:spcPts val="800"/>
-              </a:spcAft>
-            </a:pPr>
-            <a:r>
-              <a:rPr sz="1450">
-                <a:solidFill>
-                  <a:srgbClr val="222222"/>
-                </a:solidFill>
-                <a:latin typeface="Calibri"/>
-              </a:rPr>
-              <a:t>•  Base de données : PostgreSQL (types MACADDR, INET, JSONB)</a:t>
-            </a:r>
-          </a:p>
-          <a:p>
-            <a:pPr>
-              <a:lnSpc>
-                <a:spcPct val="108000"/>
-              </a:lnSpc>
-              <a:spcAft>
-                <a:spcPts val="800"/>
-              </a:spcAft>
-            </a:pPr>
-            <a:r>
-              <a:rPr sz="1450">
-                <a:solidFill>
-                  <a:srgbClr val="222222"/>
-                </a:solidFill>
-                <a:latin typeface="Calibri"/>
-              </a:rPr>
-              <a:t>•  Frontend : React (tableau de bord, servi par Nginx)</a:t>
-            </a:r>
-          </a:p>
-          <a:p>
-            <a:pPr>
-              <a:lnSpc>
-                <a:spcPct val="108000"/>
-              </a:lnSpc>
-              <a:spcAft>
-                <a:spcPts val="800"/>
-              </a:spcAft>
-            </a:pPr>
-            <a:r>
-              <a:rPr sz="1450">
-                <a:solidFill>
-                  <a:srgbClr val="222222"/>
-                </a:solidFill>
-                <a:latin typeface="Calibri"/>
-              </a:rPr>
-              <a:t>•  Déploiement : Docker / Docker Compose  ·  Versionnage : Git / GitHub</a:t>
-            </a:r>
-          </a:p>
-        </p:txBody>
-      </p:sp>
-      <p:sp>
-        <p:nvSpPr>
-          <p:cNvPr id="25" name="TextBox 24"/>
-          <p:cNvSpPr txBox="1"/>
-          <p:nvPr/>
-        </p:nvSpPr>
-        <p:spPr>
-          <a:xfrm>
-            <a:off x="502920" y="6473952"/>
-            <a:ext cx="5486400" cy="320040"/>
-          </a:xfrm>
-          <a:prstGeom prst="rect">
-            <a:avLst/>
-          </a:prstGeom>
-          <a:noFill/>
-        </p:spPr>
-        <p:txBody>
-          <a:bodyPr wrap="square" anchor="t">
-            <a:spAutoFit/>
-          </a:bodyPr>
-          <a:lstStyle/>
-          <a:p>
-            <a:pPr algn="l">
-              <a:lnSpc>
-                <a:spcPct val="100000"/>
-              </a:lnSpc>
-            </a:pPr>
-            <a:r>
               <a:rPr sz="900" b="0" i="0">
                 <a:solidFill>
                   <a:srgbClr val="5A5A5A"/>
@@ -4888,7 +4172,7 @@
       </p:sp>
       <p:sp>
         <p:nvSpPr>
-          <p:cNvPr id="26" name="TextBox 25"/>
+          <p:cNvPr id="9" name="TextBox 8"/>
           <p:cNvSpPr txBox="1"/>
           <p:nvPr/>
         </p:nvSpPr>
@@ -5004,7 +4288,7 @@
         <p:spPr>
           <a:xfrm>
             <a:off x="502920" y="73152"/>
-            <a:ext cx="7315200" cy="320040"/>
+            <a:ext cx="9144000" cy="320040"/>
           </a:xfrm>
           <a:prstGeom prst="rect">
             <a:avLst/>
@@ -5029,7 +4313,7 @@
                 </a:solidFill>
                 <a:latin typeface="Calibri"/>
               </a:rPr>
-              <a:t>7. PLANNING ET ORGANISATION DU TRAVAIL</a:t>
+              <a:t>3. ARCHITECTURE TECHNIQUE ET TECHNOLOGIES</a:t>
             </a:r>
           </a:p>
         </p:txBody>
@@ -5068,7 +4352,7 @@
                 </a:solidFill>
                 <a:latin typeface="Georgia"/>
               </a:rPr>
-              <a:t>Planning prévisionnel</a:t>
+              <a:t>Technologies utilisées</a:t>
             </a:r>
           </a:p>
         </p:txBody>
@@ -5117,9 +4401,53 @@
           </a:p>
         </p:txBody>
       </p:sp>
+      <p:sp>
+        <p:nvSpPr>
+          <p:cNvPr id="6" name="Rectangle 5"/>
+          <p:cNvSpPr/>
+          <p:nvPr/>
+        </p:nvSpPr>
+        <p:spPr>
+          <a:xfrm>
+            <a:off x="685800" y="1920240"/>
+            <a:ext cx="1783080" cy="2011680"/>
+          </a:xfrm>
+          <a:prstGeom prst="rect">
+            <a:avLst/>
+          </a:prstGeom>
+          <a:solidFill>
+            <a:srgbClr val="EFF3E9"/>
+          </a:solidFill>
+          <a:ln>
+            <a:noFill/>
+          </a:ln>
+          <a:effectLst/>
+        </p:spPr>
+        <p:style>
+          <a:lnRef idx="1">
+            <a:schemeClr val="accent1"/>
+          </a:lnRef>
+          <a:fillRef idx="3">
+            <a:schemeClr val="accent1"/>
+          </a:fillRef>
+          <a:effectRef idx="2">
+            <a:schemeClr val="accent1"/>
+          </a:effectRef>
+          <a:fontRef idx="minor">
+            <a:schemeClr val="lt1"/>
+          </a:fontRef>
+        </p:style>
+        <p:txBody>
+          <a:bodyPr rtlCol="0" anchor="ctr"/>
+          <a:lstStyle/>
+          <a:p>
+            <a:pPr algn="ctr"/>
+          </a:p>
+        </p:txBody>
+      </p:sp>
       <p:pic>
         <p:nvPicPr>
-          <p:cNvPr id="6" name="Picture 5" descr="gantt_planning.png"/>
+          <p:cNvPr id="7" name="Picture 6" descr="nodejs.png"/>
           <p:cNvPicPr>
             <a:picLocks noChangeAspect="1"/>
           </p:cNvPicPr>
@@ -5133,8 +4461,8 @@
         </p:blipFill>
         <p:spPr>
           <a:xfrm>
-            <a:off x="2045033" y="1371600"/>
-            <a:ext cx="8071452" cy="3108960"/>
+            <a:off x="822960" y="2235422"/>
+            <a:ext cx="1508760" cy="924115"/>
           </a:xfrm>
           <a:prstGeom prst="rect">
             <a:avLst/>
@@ -5143,14 +4471,14 @@
       </p:pic>
       <p:sp>
         <p:nvSpPr>
-          <p:cNvPr id="7" name="TextBox 6"/>
+          <p:cNvPr id="8" name="TextBox 7"/>
           <p:cNvSpPr txBox="1"/>
           <p:nvPr/>
         </p:nvSpPr>
         <p:spPr>
           <a:xfrm>
-            <a:off x="502920" y="6473952"/>
-            <a:ext cx="5486400" cy="320040"/>
+            <a:off x="685800" y="3429000"/>
+            <a:ext cx="1783080" cy="365760"/>
           </a:xfrm>
           <a:prstGeom prst="rect">
             <a:avLst/>
@@ -5163,6 +4491,679 @@
           </a:bodyPr>
           <a:lstStyle/>
           <a:p>
+            <a:pPr algn="ctr">
+              <a:lnSpc>
+                <a:spcPct val="100000"/>
+              </a:lnSpc>
+            </a:pPr>
+            <a:r>
+              <a:rPr sz="1300" b="1" i="0">
+                <a:solidFill>
+                  <a:srgbClr val="3A491E"/>
+                </a:solidFill>
+                <a:latin typeface="Calibri"/>
+              </a:rPr>
+              <a:t>Node.js</a:t>
+            </a:r>
+          </a:p>
+        </p:txBody>
+      </p:sp>
+      <p:sp>
+        <p:nvSpPr>
+          <p:cNvPr id="9" name="Rectangle 8"/>
+          <p:cNvSpPr/>
+          <p:nvPr/>
+        </p:nvSpPr>
+        <p:spPr>
+          <a:xfrm>
+            <a:off x="2606040" y="1920240"/>
+            <a:ext cx="1783080" cy="2011680"/>
+          </a:xfrm>
+          <a:prstGeom prst="rect">
+            <a:avLst/>
+          </a:prstGeom>
+          <a:solidFill>
+            <a:srgbClr val="EFF3E9"/>
+          </a:solidFill>
+          <a:ln>
+            <a:noFill/>
+          </a:ln>
+          <a:effectLst/>
+        </p:spPr>
+        <p:style>
+          <a:lnRef idx="1">
+            <a:schemeClr val="accent1"/>
+          </a:lnRef>
+          <a:fillRef idx="3">
+            <a:schemeClr val="accent1"/>
+          </a:fillRef>
+          <a:effectRef idx="2">
+            <a:schemeClr val="accent1"/>
+          </a:effectRef>
+          <a:fontRef idx="minor">
+            <a:schemeClr val="lt1"/>
+          </a:fontRef>
+        </p:style>
+        <p:txBody>
+          <a:bodyPr rtlCol="0" anchor="ctr"/>
+          <a:lstStyle/>
+          <a:p>
+            <a:pPr algn="ctr"/>
+          </a:p>
+        </p:txBody>
+      </p:sp>
+      <p:pic>
+        <p:nvPicPr>
+          <p:cNvPr id="10" name="Picture 9" descr="express.png"/>
+          <p:cNvPicPr>
+            <a:picLocks noChangeAspect="1"/>
+          </p:cNvPicPr>
+          <p:nvPr/>
+        </p:nvPicPr>
+        <p:blipFill>
+          <a:blip r:embed="rId3"/>
+          <a:stretch>
+            <a:fillRect/>
+          </a:stretch>
+        </p:blipFill>
+        <p:spPr>
+          <a:xfrm>
+            <a:off x="2743200" y="2468732"/>
+            <a:ext cx="1508760" cy="457494"/>
+          </a:xfrm>
+          <a:prstGeom prst="rect">
+            <a:avLst/>
+          </a:prstGeom>
+        </p:spPr>
+      </p:pic>
+      <p:sp>
+        <p:nvSpPr>
+          <p:cNvPr id="11" name="TextBox 10"/>
+          <p:cNvSpPr txBox="1"/>
+          <p:nvPr/>
+        </p:nvSpPr>
+        <p:spPr>
+          <a:xfrm>
+            <a:off x="2606040" y="3429000"/>
+            <a:ext cx="1783080" cy="365760"/>
+          </a:xfrm>
+          <a:prstGeom prst="rect">
+            <a:avLst/>
+          </a:prstGeom>
+          <a:noFill/>
+        </p:spPr>
+        <p:txBody>
+          <a:bodyPr wrap="square" anchor="t">
+            <a:spAutoFit/>
+          </a:bodyPr>
+          <a:lstStyle/>
+          <a:p>
+            <a:pPr algn="ctr">
+              <a:lnSpc>
+                <a:spcPct val="100000"/>
+              </a:lnSpc>
+            </a:pPr>
+            <a:r>
+              <a:rPr sz="1300" b="1" i="0">
+                <a:solidFill>
+                  <a:srgbClr val="3A491E"/>
+                </a:solidFill>
+                <a:latin typeface="Calibri"/>
+              </a:rPr>
+              <a:t>Express</a:t>
+            </a:r>
+          </a:p>
+        </p:txBody>
+      </p:sp>
+      <p:sp>
+        <p:nvSpPr>
+          <p:cNvPr id="12" name="Rectangle 11"/>
+          <p:cNvSpPr/>
+          <p:nvPr/>
+        </p:nvSpPr>
+        <p:spPr>
+          <a:xfrm>
+            <a:off x="4526280" y="1920240"/>
+            <a:ext cx="1783080" cy="2011680"/>
+          </a:xfrm>
+          <a:prstGeom prst="rect">
+            <a:avLst/>
+          </a:prstGeom>
+          <a:solidFill>
+            <a:srgbClr val="EFF3E9"/>
+          </a:solidFill>
+          <a:ln>
+            <a:noFill/>
+          </a:ln>
+          <a:effectLst/>
+        </p:spPr>
+        <p:style>
+          <a:lnRef idx="1">
+            <a:schemeClr val="accent1"/>
+          </a:lnRef>
+          <a:fillRef idx="3">
+            <a:schemeClr val="accent1"/>
+          </a:fillRef>
+          <a:effectRef idx="2">
+            <a:schemeClr val="accent1"/>
+          </a:effectRef>
+          <a:fontRef idx="minor">
+            <a:schemeClr val="lt1"/>
+          </a:fontRef>
+        </p:style>
+        <p:txBody>
+          <a:bodyPr rtlCol="0" anchor="ctr"/>
+          <a:lstStyle/>
+          <a:p>
+            <a:pPr algn="ctr"/>
+          </a:p>
+        </p:txBody>
+      </p:sp>
+      <p:pic>
+        <p:nvPicPr>
+          <p:cNvPr id="13" name="Picture 12" descr="postgresql.png"/>
+          <p:cNvPicPr>
+            <a:picLocks noChangeAspect="1"/>
+          </p:cNvPicPr>
+          <p:nvPr/>
+        </p:nvPicPr>
+        <p:blipFill>
+          <a:blip r:embed="rId4"/>
+          <a:stretch>
+            <a:fillRect/>
+          </a:stretch>
+        </p:blipFill>
+        <p:spPr>
+          <a:xfrm>
+            <a:off x="4841470" y="2103120"/>
+            <a:ext cx="1152698" cy="1188720"/>
+          </a:xfrm>
+          <a:prstGeom prst="rect">
+            <a:avLst/>
+          </a:prstGeom>
+        </p:spPr>
+      </p:pic>
+      <p:sp>
+        <p:nvSpPr>
+          <p:cNvPr id="14" name="TextBox 13"/>
+          <p:cNvSpPr txBox="1"/>
+          <p:nvPr/>
+        </p:nvSpPr>
+        <p:spPr>
+          <a:xfrm>
+            <a:off x="4526280" y="3429000"/>
+            <a:ext cx="1783080" cy="365760"/>
+          </a:xfrm>
+          <a:prstGeom prst="rect">
+            <a:avLst/>
+          </a:prstGeom>
+          <a:noFill/>
+        </p:spPr>
+        <p:txBody>
+          <a:bodyPr wrap="square" anchor="t">
+            <a:spAutoFit/>
+          </a:bodyPr>
+          <a:lstStyle/>
+          <a:p>
+            <a:pPr algn="ctr">
+              <a:lnSpc>
+                <a:spcPct val="100000"/>
+              </a:lnSpc>
+            </a:pPr>
+            <a:r>
+              <a:rPr sz="1300" b="1" i="0">
+                <a:solidFill>
+                  <a:srgbClr val="3A491E"/>
+                </a:solidFill>
+                <a:latin typeface="Calibri"/>
+              </a:rPr>
+              <a:t>PostgreSQL</a:t>
+            </a:r>
+          </a:p>
+        </p:txBody>
+      </p:sp>
+      <p:sp>
+        <p:nvSpPr>
+          <p:cNvPr id="15" name="Rectangle 14"/>
+          <p:cNvSpPr/>
+          <p:nvPr/>
+        </p:nvSpPr>
+        <p:spPr>
+          <a:xfrm>
+            <a:off x="6446520" y="1920240"/>
+            <a:ext cx="1783080" cy="2011680"/>
+          </a:xfrm>
+          <a:prstGeom prst="rect">
+            <a:avLst/>
+          </a:prstGeom>
+          <a:solidFill>
+            <a:srgbClr val="EFF3E9"/>
+          </a:solidFill>
+          <a:ln>
+            <a:noFill/>
+          </a:ln>
+          <a:effectLst/>
+        </p:spPr>
+        <p:style>
+          <a:lnRef idx="1">
+            <a:schemeClr val="accent1"/>
+          </a:lnRef>
+          <a:fillRef idx="3">
+            <a:schemeClr val="accent1"/>
+          </a:fillRef>
+          <a:effectRef idx="2">
+            <a:schemeClr val="accent1"/>
+          </a:effectRef>
+          <a:fontRef idx="minor">
+            <a:schemeClr val="lt1"/>
+          </a:fontRef>
+        </p:style>
+        <p:txBody>
+          <a:bodyPr rtlCol="0" anchor="ctr"/>
+          <a:lstStyle/>
+          <a:p>
+            <a:pPr algn="ctr"/>
+          </a:p>
+        </p:txBody>
+      </p:sp>
+      <p:pic>
+        <p:nvPicPr>
+          <p:cNvPr id="16" name="Picture 15" descr="react.png"/>
+          <p:cNvPicPr>
+            <a:picLocks noChangeAspect="1"/>
+          </p:cNvPicPr>
+          <p:nvPr/>
+        </p:nvPicPr>
+        <p:blipFill>
+          <a:blip r:embed="rId5"/>
+          <a:stretch>
+            <a:fillRect/>
+          </a:stretch>
+        </p:blipFill>
+        <p:spPr>
+          <a:xfrm>
+            <a:off x="6692893" y="2103120"/>
+            <a:ext cx="1290333" cy="1188720"/>
+          </a:xfrm>
+          <a:prstGeom prst="rect">
+            <a:avLst/>
+          </a:prstGeom>
+        </p:spPr>
+      </p:pic>
+      <p:sp>
+        <p:nvSpPr>
+          <p:cNvPr id="17" name="TextBox 16"/>
+          <p:cNvSpPr txBox="1"/>
+          <p:nvPr/>
+        </p:nvSpPr>
+        <p:spPr>
+          <a:xfrm>
+            <a:off x="6446520" y="3429000"/>
+            <a:ext cx="1783080" cy="365760"/>
+          </a:xfrm>
+          <a:prstGeom prst="rect">
+            <a:avLst/>
+          </a:prstGeom>
+          <a:noFill/>
+        </p:spPr>
+        <p:txBody>
+          <a:bodyPr wrap="square" anchor="t">
+            <a:spAutoFit/>
+          </a:bodyPr>
+          <a:lstStyle/>
+          <a:p>
+            <a:pPr algn="ctr">
+              <a:lnSpc>
+                <a:spcPct val="100000"/>
+              </a:lnSpc>
+            </a:pPr>
+            <a:r>
+              <a:rPr sz="1300" b="1" i="0">
+                <a:solidFill>
+                  <a:srgbClr val="3A491E"/>
+                </a:solidFill>
+                <a:latin typeface="Calibri"/>
+              </a:rPr>
+              <a:t>React</a:t>
+            </a:r>
+          </a:p>
+        </p:txBody>
+      </p:sp>
+      <p:sp>
+        <p:nvSpPr>
+          <p:cNvPr id="18" name="Rectangle 17"/>
+          <p:cNvSpPr/>
+          <p:nvPr/>
+        </p:nvSpPr>
+        <p:spPr>
+          <a:xfrm>
+            <a:off x="8366760" y="1920240"/>
+            <a:ext cx="1783080" cy="2011680"/>
+          </a:xfrm>
+          <a:prstGeom prst="rect">
+            <a:avLst/>
+          </a:prstGeom>
+          <a:solidFill>
+            <a:srgbClr val="EFF3E9"/>
+          </a:solidFill>
+          <a:ln>
+            <a:noFill/>
+          </a:ln>
+          <a:effectLst/>
+        </p:spPr>
+        <p:style>
+          <a:lnRef idx="1">
+            <a:schemeClr val="accent1"/>
+          </a:lnRef>
+          <a:fillRef idx="3">
+            <a:schemeClr val="accent1"/>
+          </a:fillRef>
+          <a:effectRef idx="2">
+            <a:schemeClr val="accent1"/>
+          </a:effectRef>
+          <a:fontRef idx="minor">
+            <a:schemeClr val="lt1"/>
+          </a:fontRef>
+        </p:style>
+        <p:txBody>
+          <a:bodyPr rtlCol="0" anchor="ctr"/>
+          <a:lstStyle/>
+          <a:p>
+            <a:pPr algn="ctr"/>
+          </a:p>
+        </p:txBody>
+      </p:sp>
+      <p:pic>
+        <p:nvPicPr>
+          <p:cNvPr id="19" name="Picture 18" descr="docker.png"/>
+          <p:cNvPicPr>
+            <a:picLocks noChangeAspect="1"/>
+          </p:cNvPicPr>
+          <p:nvPr/>
+        </p:nvPicPr>
+        <p:blipFill>
+          <a:blip r:embed="rId6"/>
+          <a:stretch>
+            <a:fillRect/>
+          </a:stretch>
+        </p:blipFill>
+        <p:spPr>
+          <a:xfrm>
+            <a:off x="8503920" y="2525858"/>
+            <a:ext cx="1508760" cy="343242"/>
+          </a:xfrm>
+          <a:prstGeom prst="rect">
+            <a:avLst/>
+          </a:prstGeom>
+        </p:spPr>
+      </p:pic>
+      <p:sp>
+        <p:nvSpPr>
+          <p:cNvPr id="20" name="TextBox 19"/>
+          <p:cNvSpPr txBox="1"/>
+          <p:nvPr/>
+        </p:nvSpPr>
+        <p:spPr>
+          <a:xfrm>
+            <a:off x="8366760" y="3429000"/>
+            <a:ext cx="1783080" cy="365760"/>
+          </a:xfrm>
+          <a:prstGeom prst="rect">
+            <a:avLst/>
+          </a:prstGeom>
+          <a:noFill/>
+        </p:spPr>
+        <p:txBody>
+          <a:bodyPr wrap="square" anchor="t">
+            <a:spAutoFit/>
+          </a:bodyPr>
+          <a:lstStyle/>
+          <a:p>
+            <a:pPr algn="ctr">
+              <a:lnSpc>
+                <a:spcPct val="100000"/>
+              </a:lnSpc>
+            </a:pPr>
+            <a:r>
+              <a:rPr sz="1300" b="1" i="0">
+                <a:solidFill>
+                  <a:srgbClr val="3A491E"/>
+                </a:solidFill>
+                <a:latin typeface="Calibri"/>
+              </a:rPr>
+              <a:t>Docker</a:t>
+            </a:r>
+          </a:p>
+        </p:txBody>
+      </p:sp>
+      <p:sp>
+        <p:nvSpPr>
+          <p:cNvPr id="21" name="Rectangle 20"/>
+          <p:cNvSpPr/>
+          <p:nvPr/>
+        </p:nvSpPr>
+        <p:spPr>
+          <a:xfrm>
+            <a:off x="10287000" y="1920240"/>
+            <a:ext cx="1783080" cy="2011680"/>
+          </a:xfrm>
+          <a:prstGeom prst="rect">
+            <a:avLst/>
+          </a:prstGeom>
+          <a:solidFill>
+            <a:srgbClr val="EFF3E9"/>
+          </a:solidFill>
+          <a:ln>
+            <a:noFill/>
+          </a:ln>
+          <a:effectLst/>
+        </p:spPr>
+        <p:style>
+          <a:lnRef idx="1">
+            <a:schemeClr val="accent1"/>
+          </a:lnRef>
+          <a:fillRef idx="3">
+            <a:schemeClr val="accent1"/>
+          </a:fillRef>
+          <a:effectRef idx="2">
+            <a:schemeClr val="accent1"/>
+          </a:effectRef>
+          <a:fontRef idx="minor">
+            <a:schemeClr val="lt1"/>
+          </a:fontRef>
+        </p:style>
+        <p:txBody>
+          <a:bodyPr rtlCol="0" anchor="ctr"/>
+          <a:lstStyle/>
+          <a:p>
+            <a:pPr algn="ctr"/>
+          </a:p>
+        </p:txBody>
+      </p:sp>
+      <p:pic>
+        <p:nvPicPr>
+          <p:cNvPr id="22" name="Picture 21" descr="git.png"/>
+          <p:cNvPicPr>
+            <a:picLocks noChangeAspect="1"/>
+          </p:cNvPicPr>
+          <p:nvPr/>
+        </p:nvPicPr>
+        <p:blipFill>
+          <a:blip r:embed="rId7"/>
+          <a:stretch>
+            <a:fillRect/>
+          </a:stretch>
+        </p:blipFill>
+        <p:spPr>
+          <a:xfrm>
+            <a:off x="10424160" y="2382526"/>
+            <a:ext cx="1508760" cy="629907"/>
+          </a:xfrm>
+          <a:prstGeom prst="rect">
+            <a:avLst/>
+          </a:prstGeom>
+        </p:spPr>
+      </p:pic>
+      <p:sp>
+        <p:nvSpPr>
+          <p:cNvPr id="23" name="TextBox 22"/>
+          <p:cNvSpPr txBox="1"/>
+          <p:nvPr/>
+        </p:nvSpPr>
+        <p:spPr>
+          <a:xfrm>
+            <a:off x="10287000" y="3429000"/>
+            <a:ext cx="1783080" cy="365760"/>
+          </a:xfrm>
+          <a:prstGeom prst="rect">
+            <a:avLst/>
+          </a:prstGeom>
+          <a:noFill/>
+        </p:spPr>
+        <p:txBody>
+          <a:bodyPr wrap="square" anchor="t">
+            <a:spAutoFit/>
+          </a:bodyPr>
+          <a:lstStyle/>
+          <a:p>
+            <a:pPr algn="ctr">
+              <a:lnSpc>
+                <a:spcPct val="100000"/>
+              </a:lnSpc>
+            </a:pPr>
+            <a:r>
+              <a:rPr sz="1300" b="1" i="0">
+                <a:solidFill>
+                  <a:srgbClr val="3A491E"/>
+                </a:solidFill>
+                <a:latin typeface="Calibri"/>
+              </a:rPr>
+              <a:t>Git</a:t>
+            </a:r>
+          </a:p>
+        </p:txBody>
+      </p:sp>
+      <p:sp>
+        <p:nvSpPr>
+          <p:cNvPr id="24" name="TextBox 23"/>
+          <p:cNvSpPr txBox="1"/>
+          <p:nvPr/>
+        </p:nvSpPr>
+        <p:spPr>
+          <a:xfrm>
+            <a:off x="685800" y="4389120"/>
+            <a:ext cx="10789920" cy="1828800"/>
+          </a:xfrm>
+          <a:prstGeom prst="rect">
+            <a:avLst/>
+          </a:prstGeom>
+          <a:noFill/>
+        </p:spPr>
+        <p:txBody>
+          <a:bodyPr wrap="square">
+            <a:spAutoFit/>
+          </a:bodyPr>
+          <a:lstStyle/>
+          <a:p>
+            <a:pPr>
+              <a:lnSpc>
+                <a:spcPct val="108000"/>
+              </a:lnSpc>
+              <a:spcAft>
+                <a:spcPts val="800"/>
+              </a:spcAft>
+            </a:pPr>
+            <a:r>
+              <a:rPr sz="1450">
+                <a:solidFill>
+                  <a:srgbClr val="222222"/>
+                </a:solidFill>
+                <a:latin typeface="Calibri"/>
+              </a:rPr>
+              <a:t>•  Backend : Node.js / Express (API REST, orchestration, JWT)</a:t>
+            </a:r>
+          </a:p>
+          <a:p>
+            <a:pPr>
+              <a:lnSpc>
+                <a:spcPct val="108000"/>
+              </a:lnSpc>
+              <a:spcAft>
+                <a:spcPts val="800"/>
+              </a:spcAft>
+            </a:pPr>
+            <a:r>
+              <a:rPr sz="1450">
+                <a:solidFill>
+                  <a:srgbClr val="222222"/>
+                </a:solidFill>
+                <a:latin typeface="Calibri"/>
+              </a:rPr>
+              <a:t>•  Base de données : PostgreSQL (types MACADDR, INET, JSONB)</a:t>
+            </a:r>
+          </a:p>
+          <a:p>
+            <a:pPr>
+              <a:lnSpc>
+                <a:spcPct val="108000"/>
+              </a:lnSpc>
+              <a:spcAft>
+                <a:spcPts val="800"/>
+              </a:spcAft>
+            </a:pPr>
+            <a:r>
+              <a:rPr sz="1450">
+                <a:solidFill>
+                  <a:srgbClr val="222222"/>
+                </a:solidFill>
+                <a:latin typeface="Calibri"/>
+              </a:rPr>
+              <a:t>•  Frontend : React (tableau de bord, servi par Nginx)</a:t>
+            </a:r>
+          </a:p>
+          <a:p>
+            <a:pPr>
+              <a:lnSpc>
+                <a:spcPct val="108000"/>
+              </a:lnSpc>
+              <a:spcAft>
+                <a:spcPts val="800"/>
+              </a:spcAft>
+            </a:pPr>
+            <a:r>
+              <a:rPr sz="1450">
+                <a:solidFill>
+                  <a:srgbClr val="222222"/>
+                </a:solidFill>
+                <a:latin typeface="Calibri"/>
+              </a:rPr>
+              <a:t>•  Déploiement : Docker / Docker Compose  ·  Versionnage : Git / GitHub</a:t>
+            </a:r>
+          </a:p>
+        </p:txBody>
+      </p:sp>
+      <p:sp>
+        <p:nvSpPr>
+          <p:cNvPr id="25" name="TextBox 24"/>
+          <p:cNvSpPr txBox="1"/>
+          <p:nvPr/>
+        </p:nvSpPr>
+        <p:spPr>
+          <a:xfrm>
+            <a:off x="502920" y="6473952"/>
+            <a:ext cx="5486400" cy="320040"/>
+          </a:xfrm>
+          <a:prstGeom prst="rect">
+            <a:avLst/>
+          </a:prstGeom>
+          <a:noFill/>
+        </p:spPr>
+        <p:txBody>
+          <a:bodyPr wrap="square" anchor="t">
+            <a:spAutoFit/>
+          </a:bodyPr>
+          <a:lstStyle/>
+          <a:p>
             <a:pPr algn="l">
               <a:lnSpc>
                 <a:spcPct val="100000"/>
@@ -5182,7 +5183,7 @@
       </p:sp>
       <p:sp>
         <p:nvSpPr>
-          <p:cNvPr id="8" name="TextBox 7"/>
+          <p:cNvPr id="26" name="TextBox 25"/>
           <p:cNvSpPr txBox="1"/>
           <p:nvPr/>
         </p:nvSpPr>
@@ -5298,7 +5299,7 @@
         <p:spPr>
           <a:xfrm>
             <a:off x="502920" y="73152"/>
-            <a:ext cx="7315200" cy="320040"/>
+            <a:ext cx="9144000" cy="320040"/>
           </a:xfrm>
           <a:prstGeom prst="rect">
             <a:avLst/>
@@ -5323,7 +5324,7 @@
                 </a:solidFill>
                 <a:latin typeface="Calibri"/>
               </a:rPr>
-              <a:t>7. PLANNING ET ORGANISATION DU TRAVAIL</a:t>
+              <a:t>3. ARCHITECTURE TECHNIQUE ET TECHNOLOGIES</a:t>
             </a:r>
           </a:p>
         </p:txBody>
@@ -5362,7 +5363,7 @@
                 </a:solidFill>
                 <a:latin typeface="Georgia"/>
               </a:rPr>
-              <a:t>Organisation du travail (Kanban)</a:t>
+              <a:t>Planning prévisionnel</a:t>
             </a:r>
           </a:p>
         </p:txBody>
@@ -5413,7 +5414,7 @@
       </p:sp>
       <p:pic>
         <p:nvPicPr>
-          <p:cNvPr id="6" name="Picture 5" descr="kanban.png"/>
+          <p:cNvPr id="6" name="Picture 5" descr="gantt_planning.png"/>
           <p:cNvPicPr>
             <a:picLocks noChangeAspect="1"/>
           </p:cNvPicPr>
@@ -5427,8 +5428,8 @@
         </p:blipFill>
         <p:spPr>
           <a:xfrm>
-            <a:off x="1325880" y="1280160"/>
-            <a:ext cx="9509760" cy="5120640"/>
+            <a:off x="2045033" y="1371600"/>
+            <a:ext cx="8071452" cy="3108960"/>
           </a:xfrm>
           <a:prstGeom prst="rect">
             <a:avLst/>
@@ -5592,7 +5593,7 @@
         <p:spPr>
           <a:xfrm>
             <a:off x="502920" y="73152"/>
-            <a:ext cx="7315200" cy="320040"/>
+            <a:ext cx="9144000" cy="320040"/>
           </a:xfrm>
           <a:prstGeom prst="rect">
             <a:avLst/>
@@ -5617,7 +5618,7 @@
                 </a:solidFill>
                 <a:latin typeface="Calibri"/>
               </a:rPr>
-              <a:t>8. DÉMONSTRATION</a:t>
+              <a:t>3. ARCHITECTURE TECHNIQUE ET TECHNOLOGIES</a:t>
             </a:r>
           </a:p>
         </p:txBody>
@@ -5656,7 +5657,7 @@
                 </a:solidFill>
                 <a:latin typeface="Georgia"/>
               </a:rPr>
-              <a:t>Démonstration — Tableau de bord</a:t>
+              <a:t>Organisation du travail (Kanban)</a:t>
             </a:r>
           </a:p>
         </p:txBody>
@@ -5707,7 +5708,7 @@
       </p:sp>
       <p:pic>
         <p:nvPicPr>
-          <p:cNvPr id="6" name="Picture 5" descr="dashboard.png"/>
+          <p:cNvPr id="6" name="Picture 5" descr="kanban.png"/>
           <p:cNvPicPr>
             <a:picLocks noChangeAspect="1"/>
           </p:cNvPicPr>
@@ -5721,8 +5722,8 @@
         </p:blipFill>
         <p:spPr>
           <a:xfrm>
-            <a:off x="1391801" y="1371600"/>
-            <a:ext cx="9377916" cy="4480560"/>
+            <a:off x="1325880" y="1280160"/>
+            <a:ext cx="9509760" cy="5120640"/>
           </a:xfrm>
           <a:prstGeom prst="rect">
             <a:avLst/>
@@ -5737,8 +5738,8 @@
         </p:nvSpPr>
         <p:spPr>
           <a:xfrm>
-            <a:off x="548640" y="5989320"/>
-            <a:ext cx="11064240" cy="457200"/>
+            <a:off x="502920" y="6473952"/>
+            <a:ext cx="5486400" cy="320040"/>
           </a:xfrm>
           <a:prstGeom prst="rect">
             <a:avLst/>
@@ -5751,19 +5752,19 @@
           </a:bodyPr>
           <a:lstStyle/>
           <a:p>
-            <a:pPr algn="ctr">
+            <a:pPr algn="l">
               <a:lnSpc>
                 <a:spcPct val="100000"/>
               </a:lnSpc>
             </a:pPr>
             <a:r>
-              <a:rPr sz="1400" b="0" i="1">
+              <a:rPr sz="900" b="0" i="0">
                 <a:solidFill>
                   <a:srgbClr val="5A5A5A"/>
                 </a:solidFill>
                 <a:latin typeface="Calibri"/>
               </a:rPr>
-              <a:t>Vue d'ensemble des appareils détectés, leur statut et déclenchement d'un scan manuel</a:t>
+              <a:t>NetSentry — Découverte et cartographie des équipements réseau</a:t>
             </a:r>
           </a:p>
         </p:txBody>
@@ -5771,45 +5772,6 @@
       <p:sp>
         <p:nvSpPr>
           <p:cNvPr id="8" name="TextBox 7"/>
-          <p:cNvSpPr txBox="1"/>
-          <p:nvPr/>
-        </p:nvSpPr>
-        <p:spPr>
-          <a:xfrm>
-            <a:off x="502920" y="6473952"/>
-            <a:ext cx="5486400" cy="320040"/>
-          </a:xfrm>
-          <a:prstGeom prst="rect">
-            <a:avLst/>
-          </a:prstGeom>
-          <a:noFill/>
-        </p:spPr>
-        <p:txBody>
-          <a:bodyPr wrap="square" anchor="t">
-            <a:spAutoFit/>
-          </a:bodyPr>
-          <a:lstStyle/>
-          <a:p>
-            <a:pPr algn="l">
-              <a:lnSpc>
-                <a:spcPct val="100000"/>
-              </a:lnSpc>
-            </a:pPr>
-            <a:r>
-              <a:rPr sz="900" b="0" i="0">
-                <a:solidFill>
-                  <a:srgbClr val="5A5A5A"/>
-                </a:solidFill>
-                <a:latin typeface="Calibri"/>
-              </a:rPr>
-              <a:t>NetSentry — Découverte et cartographie des équipements réseau</a:t>
-            </a:r>
-          </a:p>
-        </p:txBody>
-      </p:sp>
-      <p:sp>
-        <p:nvSpPr>
-          <p:cNvPr id="9" name="TextBox 8"/>
           <p:cNvSpPr txBox="1"/>
           <p:nvPr/>
         </p:nvSpPr>
@@ -5925,7 +5887,7 @@
         <p:spPr>
           <a:xfrm>
             <a:off x="502920" y="73152"/>
-            <a:ext cx="7315200" cy="320040"/>
+            <a:ext cx="9144000" cy="320040"/>
           </a:xfrm>
           <a:prstGeom prst="rect">
             <a:avLst/>
@@ -5950,7 +5912,7 @@
                 </a:solidFill>
                 <a:latin typeface="Calibri"/>
               </a:rPr>
-              <a:t>8. DÉMONSTRATION</a:t>
+              <a:t>4. MISE EN ŒUVRE ET CAPTURES D'ÉCRAN</a:t>
             </a:r>
           </a:p>
         </p:txBody>
@@ -5989,7 +5951,7 @@
                 </a:solidFill>
                 <a:latin typeface="Georgia"/>
               </a:rPr>
-              <a:t>Démonstration — Détail d'un appareil</a:t>
+              <a:t>Démonstration — Tableau de bord</a:t>
             </a:r>
           </a:p>
         </p:txBody>
@@ -6040,7 +6002,7 @@
       </p:sp>
       <p:pic>
         <p:nvPicPr>
-          <p:cNvPr id="6" name="Picture 5" descr="device_detail.png"/>
+          <p:cNvPr id="6" name="Picture 5" descr="dashboard.png"/>
           <p:cNvPicPr>
             <a:picLocks noChangeAspect="1"/>
           </p:cNvPicPr>
@@ -6054,8 +6016,8 @@
         </p:blipFill>
         <p:spPr>
           <a:xfrm>
-            <a:off x="548640" y="1425924"/>
-            <a:ext cx="11064240" cy="4371911"/>
+            <a:off x="1391801" y="1371600"/>
+            <a:ext cx="9377916" cy="4480560"/>
           </a:xfrm>
           <a:prstGeom prst="rect">
             <a:avLst/>
@@ -6096,7 +6058,7 @@
                 </a:solidFill>
                 <a:latin typeface="Calibri"/>
               </a:rPr>
-              <a:t>Historique de détection et mise en liste blanche ("connu")</a:t>
+              <a:t>Vue d'ensemble des appareils détectés, leur statut et déclenchement d'un scan manuel</a:t>
             </a:r>
           </a:p>
         </p:txBody>
@@ -6258,7 +6220,7 @@
         <p:spPr>
           <a:xfrm>
             <a:off x="502920" y="73152"/>
-            <a:ext cx="7315200" cy="320040"/>
+            <a:ext cx="9144000" cy="320040"/>
           </a:xfrm>
           <a:prstGeom prst="rect">
             <a:avLst/>
@@ -6283,7 +6245,7 @@
                 </a:solidFill>
                 <a:latin typeface="Calibri"/>
               </a:rPr>
-              <a:t>8. DÉMONSTRATION</a:t>
+              <a:t>4. MISE EN ŒUVRE ET CAPTURES D'ÉCRAN</a:t>
             </a:r>
           </a:p>
         </p:txBody>
@@ -6322,7 +6284,7 @@
                 </a:solidFill>
                 <a:latin typeface="Georgia"/>
               </a:rPr>
-              <a:t>Démonstration — Alertes</a:t>
+              <a:t>Démonstration — Détail d'un appareil</a:t>
             </a:r>
           </a:p>
         </p:txBody>
@@ -6373,7 +6335,7 @@
       </p:sp>
       <p:pic>
         <p:nvPicPr>
-          <p:cNvPr id="6" name="Picture 5" descr="alerts.png"/>
+          <p:cNvPr id="6" name="Picture 5" descr="device_detail.png"/>
           <p:cNvPicPr>
             <a:picLocks noChangeAspect="1"/>
           </p:cNvPicPr>
@@ -6387,8 +6349,8 @@
         </p:blipFill>
         <p:spPr>
           <a:xfrm>
-            <a:off x="1472184" y="1371600"/>
-            <a:ext cx="9217152" cy="4480560"/>
+            <a:off x="548640" y="1425924"/>
+            <a:ext cx="11064240" cy="4371911"/>
           </a:xfrm>
           <a:prstGeom prst="rect">
             <a:avLst/>
@@ -6429,7 +6391,7 @@
                 </a:solidFill>
                 <a:latin typeface="Calibri"/>
               </a:rPr>
-              <a:t>Appareils non reconnus signalés après un scan</a:t>
+              <a:t>Historique de détection et mise en liste blanche ("connu")</a:t>
             </a:r>
           </a:p>
         </p:txBody>
@@ -6591,7 +6553,7 @@
         <p:spPr>
           <a:xfrm>
             <a:off x="502920" y="73152"/>
-            <a:ext cx="7315200" cy="320040"/>
+            <a:ext cx="9144000" cy="320040"/>
           </a:xfrm>
           <a:prstGeom prst="rect">
             <a:avLst/>
@@ -6616,7 +6578,7 @@
                 </a:solidFill>
                 <a:latin typeface="Calibri"/>
               </a:rPr>
-              <a:t>8. DÉMONSTRATION</a:t>
+              <a:t>4. MISE EN ŒUVRE ET CAPTURES D'ÉCRAN</a:t>
             </a:r>
           </a:p>
         </p:txBody>
@@ -6655,7 +6617,7 @@
                 </a:solidFill>
                 <a:latin typeface="Georgia"/>
               </a:rPr>
-              <a:t>Démonstration — Historique des scans</a:t>
+              <a:t>Démonstration — Alertes</a:t>
             </a:r>
           </a:p>
         </p:txBody>
@@ -6706,7 +6668,7 @@
       </p:sp>
       <p:pic>
         <p:nvPicPr>
-          <p:cNvPr id="6" name="Picture 5" descr="scan_history.png"/>
+          <p:cNvPr id="6" name="Picture 5" descr="alerts.png"/>
           <p:cNvPicPr>
             <a:picLocks noChangeAspect="1"/>
           </p:cNvPicPr>
@@ -6720,8 +6682,8 @@
         </p:blipFill>
         <p:spPr>
           <a:xfrm>
-            <a:off x="548640" y="1971452"/>
-            <a:ext cx="11064240" cy="3280854"/>
+            <a:off x="1472184" y="1371600"/>
+            <a:ext cx="9217152" cy="4480560"/>
           </a:xfrm>
           <a:prstGeom prst="rect">
             <a:avLst/>
@@ -6762,7 +6724,7 @@
                 </a:solidFill>
                 <a:latin typeface="Calibri"/>
               </a:rPr>
-              <a:t>Trace de chaque exécution, manuelle ou planifiée</a:t>
+              <a:t>Appareils non reconnus signalés après un scan</a:t>
             </a:r>
           </a:p>
         </p:txBody>
@@ -6924,7 +6886,7 @@
         <p:spPr>
           <a:xfrm>
             <a:off x="502920" y="73152"/>
-            <a:ext cx="7315200" cy="320040"/>
+            <a:ext cx="9144000" cy="320040"/>
           </a:xfrm>
           <a:prstGeom prst="rect">
             <a:avLst/>
@@ -6949,7 +6911,7 @@
                 </a:solidFill>
                 <a:latin typeface="Calibri"/>
               </a:rPr>
-              <a:t>8. DÉMONSTRATION</a:t>
+              <a:t>4. MISE EN ŒUVRE ET CAPTURES D'ÉCRAN</a:t>
             </a:r>
           </a:p>
         </p:txBody>
@@ -6988,7 +6950,7 @@
                 </a:solidFill>
                 <a:latin typeface="Georgia"/>
               </a:rPr>
-              <a:t>Versionnage</a:t>
+              <a:t>Démonstration — Historique des scans</a:t>
             </a:r>
           </a:p>
         </p:txBody>
@@ -7039,7 +7001,7 @@
       </p:sp>
       <p:pic>
         <p:nvPicPr>
-          <p:cNvPr id="6" name="Picture 5" descr="github_commits.png"/>
+          <p:cNvPr id="6" name="Picture 5" descr="scan_history.png"/>
           <p:cNvPicPr>
             <a:picLocks noChangeAspect="1"/>
           </p:cNvPicPr>
@@ -7053,8 +7015,8 @@
         </p:blipFill>
         <p:spPr>
           <a:xfrm>
-            <a:off x="1688054" y="1371600"/>
-            <a:ext cx="8785411" cy="4480560"/>
+            <a:off x="548640" y="1971452"/>
+            <a:ext cx="11064240" cy="3280854"/>
           </a:xfrm>
           <a:prstGeom prst="rect">
             <a:avLst/>
@@ -7069,8 +7031,8 @@
         </p:nvSpPr>
         <p:spPr>
           <a:xfrm>
-            <a:off x="502920" y="6473952"/>
-            <a:ext cx="5486400" cy="320040"/>
+            <a:off x="548640" y="5989320"/>
+            <a:ext cx="11064240" cy="457200"/>
           </a:xfrm>
           <a:prstGeom prst="rect">
             <a:avLst/>
@@ -7083,6 +7045,45 @@
           </a:bodyPr>
           <a:lstStyle/>
           <a:p>
+            <a:pPr algn="ctr">
+              <a:lnSpc>
+                <a:spcPct val="100000"/>
+              </a:lnSpc>
+            </a:pPr>
+            <a:r>
+              <a:rPr sz="1400" b="0" i="1">
+                <a:solidFill>
+                  <a:srgbClr val="5A5A5A"/>
+                </a:solidFill>
+                <a:latin typeface="Calibri"/>
+              </a:rPr>
+              <a:t>Trace de chaque exécution, manuelle ou planifiée</a:t>
+            </a:r>
+          </a:p>
+        </p:txBody>
+      </p:sp>
+      <p:sp>
+        <p:nvSpPr>
+          <p:cNvPr id="8" name="TextBox 7"/>
+          <p:cNvSpPr txBox="1"/>
+          <p:nvPr/>
+        </p:nvSpPr>
+        <p:spPr>
+          <a:xfrm>
+            <a:off x="502920" y="6473952"/>
+            <a:ext cx="5486400" cy="320040"/>
+          </a:xfrm>
+          <a:prstGeom prst="rect">
+            <a:avLst/>
+          </a:prstGeom>
+          <a:noFill/>
+        </p:spPr>
+        <p:txBody>
+          <a:bodyPr wrap="square" anchor="t">
+            <a:spAutoFit/>
+          </a:bodyPr>
+          <a:lstStyle/>
+          <a:p>
             <a:pPr algn="l">
               <a:lnSpc>
                 <a:spcPct val="100000"/>
@@ -7102,7 +7103,7 @@
       </p:sp>
       <p:sp>
         <p:nvSpPr>
-          <p:cNvPr id="8" name="TextBox 7"/>
+          <p:cNvPr id="9" name="TextBox 8"/>
           <p:cNvSpPr txBox="1"/>
           <p:nvPr/>
         </p:nvSpPr>
@@ -7218,7 +7219,7 @@
         <p:spPr>
           <a:xfrm>
             <a:off x="502920" y="73152"/>
-            <a:ext cx="7315200" cy="320040"/>
+            <a:ext cx="9144000" cy="320040"/>
           </a:xfrm>
           <a:prstGeom prst="rect">
             <a:avLst/>
@@ -7243,7 +7244,7 @@
                 </a:solidFill>
                 <a:latin typeface="Calibri"/>
               </a:rPr>
-              <a:t>9. BILAN ET PERSPECTIVES</a:t>
+              <a:t>4. MISE EN ŒUVRE ET CAPTURES D'ÉCRAN</a:t>
             </a:r>
           </a:p>
         </p:txBody>
@@ -7282,7 +7283,7 @@
                 </a:solidFill>
                 <a:latin typeface="Georgia"/>
               </a:rPr>
-              <a:t>Bilan</a:t>
+              <a:t>Versionnage</a:t>
             </a:r>
           </a:p>
         </p:txBody>
@@ -7331,105 +7332,30 @@
           </a:p>
         </p:txBody>
       </p:sp>
-      <p:sp>
-        <p:nvSpPr>
-          <p:cNvPr id="6" name="TextBox 5"/>
-          <p:cNvSpPr txBox="1"/>
-          <p:nvPr/>
-        </p:nvSpPr>
-        <p:spPr>
-          <a:xfrm>
-            <a:off x="640080" y="1463040"/>
-            <a:ext cx="10789920" cy="4754880"/>
-          </a:xfrm>
-          <a:prstGeom prst="rect">
-            <a:avLst/>
-          </a:prstGeom>
-          <a:noFill/>
-        </p:spPr>
-        <p:txBody>
-          <a:bodyPr wrap="square">
-            <a:spAutoFit/>
-          </a:bodyPr>
-          <a:lstStyle/>
-          <a:p>
-            <a:pPr>
-              <a:lnSpc>
-                <a:spcPct val="108000"/>
-              </a:lnSpc>
-              <a:spcAft>
-                <a:spcPts val="1800"/>
-              </a:spcAft>
-            </a:pPr>
-            <a:r>
-              <a:rPr sz="1750">
-                <a:solidFill>
-                  <a:srgbClr val="222222"/>
-                </a:solidFill>
-                <a:latin typeface="Calibri"/>
-              </a:rPr>
-              <a:t>•  Chaîne complète vérifiée de bout en bout : scan → backend → tableau de bord → déploiement conteneurisé</a:t>
-            </a:r>
-          </a:p>
-          <a:p>
-            <a:pPr>
-              <a:lnSpc>
-                <a:spcPct val="108000"/>
-              </a:lnSpc>
-              <a:spcAft>
-                <a:spcPts val="1800"/>
-              </a:spcAft>
-            </a:pPr>
-            <a:r>
-              <a:rPr sz="1750">
-                <a:solidFill>
-                  <a:srgbClr val="222222"/>
-                </a:solidFill>
-                <a:latin typeface="Calibri"/>
-              </a:rPr>
-              <a:t>•  Compétences renforcées : réseau (ARP, MAC, ports), développement full-stack, sécurité (JWT), conteneurisation</a:t>
-            </a:r>
-          </a:p>
-          <a:p>
-            <a:pPr>
-              <a:lnSpc>
-                <a:spcPct val="108000"/>
-              </a:lnSpc>
-              <a:spcAft>
-                <a:spcPts val="1800"/>
-              </a:spcAft>
-            </a:pPr>
-            <a:r>
-              <a:rPr sz="1750">
-                <a:solidFill>
-                  <a:srgbClr val="222222"/>
-                </a:solidFill>
-                <a:latin typeface="Calibri"/>
-              </a:rPr>
-              <a:t>•  Principale difficulté : périmètre limité aux systèmes réellement accessibles au département IT interne</a:t>
-            </a:r>
-          </a:p>
-          <a:p>
-            <a:pPr>
-              <a:lnSpc>
-                <a:spcPct val="108000"/>
-              </a:lnSpc>
-              <a:spcAft>
-                <a:spcPts val="1800"/>
-              </a:spcAft>
-            </a:pPr>
-            <a:r>
-              <a:rPr sz="1750">
-                <a:solidFill>
-                  <a:srgbClr val="222222"/>
-                </a:solidFill>
-                <a:latin typeface="Calibri"/>
-              </a:rPr>
-              <a:t>•  Limite assumée : adresses MAC aléatoires → fabricant "inconnu" pour certains appareils, par conception</a:t>
-            </a:r>
-          </a:p>
-        </p:txBody>
-      </p:sp>
+      <p:pic>
+        <p:nvPicPr>
+          <p:cNvPr id="6" name="Picture 5" descr="github_commits.png"/>
+          <p:cNvPicPr>
+            <a:picLocks noChangeAspect="1"/>
+          </p:cNvPicPr>
+          <p:nvPr/>
+        </p:nvPicPr>
+        <p:blipFill>
+          <a:blip r:embed="rId2"/>
+          <a:stretch>
+            <a:fillRect/>
+          </a:stretch>
+        </p:blipFill>
+        <p:spPr>
+          <a:xfrm>
+            <a:off x="1688054" y="1371600"/>
+            <a:ext cx="8785411" cy="4480560"/>
+          </a:xfrm>
+          <a:prstGeom prst="rect">
+            <a:avLst/>
+          </a:prstGeom>
+        </p:spPr>
+      </p:pic>
       <p:sp>
         <p:nvSpPr>
           <p:cNvPr id="7" name="TextBox 6"/>
@@ -7669,8 +7595,8 @@
         </p:nvSpPr>
         <p:spPr>
           <a:xfrm>
-            <a:off x="914400" y="1508760"/>
-            <a:ext cx="8229600" cy="5029200"/>
+            <a:off x="914400" y="1737360"/>
+            <a:ext cx="9144000" cy="4114800"/>
           </a:xfrm>
           <a:prstGeom prst="rect">
             <a:avLst/>
@@ -7688,17 +7614,17 @@
                 <a:spcPct val="108000"/>
               </a:lnSpc>
               <a:spcAft>
-                <a:spcPts val="1300"/>
+                <a:spcPts val="2600"/>
               </a:spcAft>
             </a:pPr>
             <a:r>
-              <a:rPr sz="1900">
+              <a:rPr sz="2400">
                 <a:solidFill>
                   <a:srgbClr val="222222"/>
                 </a:solidFill>
                 <a:latin typeface="Calibri"/>
               </a:rPr>
-              <a:t>•  1.  Contexte et problématique</a:t>
+              <a:t>•  1.  Contexte général</a:t>
             </a:r>
           </a:p>
           <a:p>
@@ -7707,17 +7633,17 @@
                 <a:spcPct val="108000"/>
               </a:lnSpc>
               <a:spcAft>
-                <a:spcPts val="1300"/>
+                <a:spcPts val="2600"/>
               </a:spcAft>
             </a:pPr>
             <a:r>
-              <a:rPr sz="1900">
+              <a:rPr sz="2400">
                 <a:solidFill>
                   <a:srgbClr val="222222"/>
                 </a:solidFill>
                 <a:latin typeface="Calibri"/>
               </a:rPr>
-              <a:t>•  2.  Objectifs du projet</a:t>
+              <a:t>•  2.  Analyse des besoins et conception</a:t>
             </a:r>
           </a:p>
           <a:p>
@@ -7726,17 +7652,17 @@
                 <a:spcPct val="108000"/>
               </a:lnSpc>
               <a:spcAft>
-                <a:spcPts val="1300"/>
+                <a:spcPts val="2600"/>
               </a:spcAft>
             </a:pPr>
             <a:r>
-              <a:rPr sz="1900">
+              <a:rPr sz="2400">
                 <a:solidFill>
                   <a:srgbClr val="222222"/>
                 </a:solidFill>
                 <a:latin typeface="Calibri"/>
               </a:rPr>
-              <a:t>•  3.  Étude de l'existant et méthodologie</a:t>
+              <a:t>•  3.  Architecture technique et technologies</a:t>
             </a:r>
           </a:p>
           <a:p>
@@ -7745,17 +7671,17 @@
                 <a:spcPct val="108000"/>
               </a:lnSpc>
               <a:spcAft>
-                <a:spcPts val="1300"/>
+                <a:spcPts val="2600"/>
               </a:spcAft>
             </a:pPr>
             <a:r>
-              <a:rPr sz="1900">
+              <a:rPr sz="2400">
                 <a:solidFill>
                   <a:srgbClr val="222222"/>
                 </a:solidFill>
                 <a:latin typeface="Calibri"/>
               </a:rPr>
-              <a:t>•  4.  Analyse et conception (UML)</a:t>
+              <a:t>•  4.  Mise en œuvre et captures d'écran</a:t>
             </a:r>
           </a:p>
           <a:p>
@@ -7764,93 +7690,17 @@
                 <a:spcPct val="108000"/>
               </a:lnSpc>
               <a:spcAft>
-                <a:spcPts val="1300"/>
+                <a:spcPts val="2600"/>
               </a:spcAft>
             </a:pPr>
             <a:r>
-              <a:rPr sz="1900">
+              <a:rPr sz="2400">
                 <a:solidFill>
                   <a:srgbClr val="222222"/>
                 </a:solidFill>
                 <a:latin typeface="Calibri"/>
               </a:rPr>
-              <a:t>•  5.  Architecture technique et technologies</a:t>
-            </a:r>
-          </a:p>
-          <a:p>
-            <a:pPr>
-              <a:lnSpc>
-                <a:spcPct val="108000"/>
-              </a:lnSpc>
-              <a:spcAft>
-                <a:spcPts val="1300"/>
-              </a:spcAft>
-            </a:pPr>
-            <a:r>
-              <a:rPr sz="1900">
-                <a:solidFill>
-                  <a:srgbClr val="222222"/>
-                </a:solidFill>
-                <a:latin typeface="Calibri"/>
-              </a:rPr>
-              <a:t>•  6.  Nmap : le moteur de découverte</a:t>
-            </a:r>
-          </a:p>
-          <a:p>
-            <a:pPr>
-              <a:lnSpc>
-                <a:spcPct val="108000"/>
-              </a:lnSpc>
-              <a:spcAft>
-                <a:spcPts val="1300"/>
-              </a:spcAft>
-            </a:pPr>
-            <a:r>
-              <a:rPr sz="1900">
-                <a:solidFill>
-                  <a:srgbClr val="222222"/>
-                </a:solidFill>
-                <a:latin typeface="Calibri"/>
-              </a:rPr>
-              <a:t>•  7.  Planning et organisation du travail</a:t>
-            </a:r>
-          </a:p>
-          <a:p>
-            <a:pPr>
-              <a:lnSpc>
-                <a:spcPct val="108000"/>
-              </a:lnSpc>
-              <a:spcAft>
-                <a:spcPts val="1300"/>
-              </a:spcAft>
-            </a:pPr>
-            <a:r>
-              <a:rPr sz="1900">
-                <a:solidFill>
-                  <a:srgbClr val="222222"/>
-                </a:solidFill>
-                <a:latin typeface="Calibri"/>
-              </a:rPr>
-              <a:t>•  8.  Démonstration</a:t>
-            </a:r>
-          </a:p>
-          <a:p>
-            <a:pPr>
-              <a:lnSpc>
-                <a:spcPct val="108000"/>
-              </a:lnSpc>
-              <a:spcAft>
-                <a:spcPts val="1300"/>
-              </a:spcAft>
-            </a:pPr>
-            <a:r>
-              <a:rPr sz="1900">
-                <a:solidFill>
-                  <a:srgbClr val="222222"/>
-                </a:solidFill>
-                <a:latin typeface="Calibri"/>
-              </a:rPr>
-              <a:t>•  9.  Bilan et perspectives</a:t>
+              <a:t>•  5.  Bilan et perspectives</a:t>
             </a:r>
           </a:p>
         </p:txBody>
@@ -8012,7 +7862,7 @@
         <p:spPr>
           <a:xfrm>
             <a:off x="502920" y="73152"/>
-            <a:ext cx="7315200" cy="320040"/>
+            <a:ext cx="9144000" cy="320040"/>
           </a:xfrm>
           <a:prstGeom prst="rect">
             <a:avLst/>
@@ -8037,7 +7887,7 @@
                 </a:solidFill>
                 <a:latin typeface="Calibri"/>
               </a:rPr>
-              <a:t>9. BILAN ET PERSPECTIVES</a:t>
+              <a:t>5. BILAN ET PERSPECTIVES</a:t>
             </a:r>
           </a:p>
         </p:txBody>
@@ -8076,7 +7926,7 @@
                 </a:solidFill>
                 <a:latin typeface="Georgia"/>
               </a:rPr>
-              <a:t>Perspectives d'évolution</a:t>
+              <a:t>Bilan</a:t>
             </a:r>
           </a:p>
         </p:txBody>
@@ -8152,17 +8002,17 @@
                 <a:spcPct val="108000"/>
               </a:lnSpc>
               <a:spcAft>
-                <a:spcPts val="2000"/>
+                <a:spcPts val="1800"/>
               </a:spcAft>
             </a:pPr>
             <a:r>
-              <a:rPr sz="1800">
+              <a:rPr sz="1750">
                 <a:solidFill>
                   <a:srgbClr val="222222"/>
                 </a:solidFill>
                 <a:latin typeface="Calibri"/>
               </a:rPr>
-              <a:t>•  Notifications par e-mail en complément de l'alerte affichée</a:t>
+              <a:t>•  Chaîne complète vérifiée de bout en bout : scan → backend → tableau de bord → déploiement conteneurisé</a:t>
             </a:r>
           </a:p>
           <a:p>
@@ -8171,17 +8021,17 @@
                 <a:spcPct val="108000"/>
               </a:lnSpc>
               <a:spcAft>
-                <a:spcPts val="2000"/>
+                <a:spcPts val="1800"/>
               </a:spcAft>
             </a:pPr>
             <a:r>
-              <a:rPr sz="1800">
+              <a:rPr sz="1750">
                 <a:solidFill>
                   <a:srgbClr val="222222"/>
                 </a:solidFill>
                 <a:latin typeface="Calibri"/>
               </a:rPr>
-              <a:t>•  Classification par type d'appareil (fabricant + ports ouverts)</a:t>
+              <a:t>•  Compétences renforcées : réseau (ARP, MAC, ports), développement full-stack, sécurité (JWT), conteneurisation</a:t>
             </a:r>
           </a:p>
           <a:p>
@@ -8190,17 +8040,17 @@
                 <a:spcPct val="108000"/>
               </a:lnSpc>
               <a:spcAft>
-                <a:spcPts val="2000"/>
+                <a:spcPts val="1800"/>
               </a:spcAft>
             </a:pPr>
             <a:r>
-              <a:rPr sz="1800">
+              <a:rPr sz="1750">
                 <a:solidFill>
                   <a:srgbClr val="222222"/>
                 </a:solidFill>
                 <a:latin typeface="Calibri"/>
               </a:rPr>
-              <a:t>•  Historique Git plus granulaire au fil des prochaines itérations</a:t>
+              <a:t>•  Principale difficulté : périmètre limité aux systèmes réellement accessibles au département IT interne</a:t>
             </a:r>
           </a:p>
           <a:p>
@@ -8209,17 +8059,17 @@
                 <a:spcPct val="108000"/>
               </a:lnSpc>
               <a:spcAft>
-                <a:spcPts val="2000"/>
+                <a:spcPts val="1800"/>
               </a:spcAft>
             </a:pPr>
             <a:r>
-              <a:rPr sz="1800">
+              <a:rPr sz="1750">
                 <a:solidFill>
                   <a:srgbClr val="222222"/>
                 </a:solidFill>
                 <a:latin typeface="Calibri"/>
               </a:rPr>
-              <a:t>•  Déploiement en production sur le serveur définitif de l'hôtel</a:t>
+              <a:t>•  Limite assumée : adresses MAC aléatoires → fabricant "inconnu" pour certains appareils, par conception</a:t>
             </a:r>
           </a:p>
         </p:txBody>
@@ -8337,6 +8187,375 @@
         <p:spPr>
           <a:xfrm>
             <a:off x="0" y="0"/>
+            <a:ext cx="12191695" cy="1051560"/>
+          </a:xfrm>
+          <a:prstGeom prst="rect">
+            <a:avLst/>
+          </a:prstGeom>
+          <a:solidFill>
+            <a:srgbClr val="4F6228"/>
+          </a:solidFill>
+          <a:ln>
+            <a:noFill/>
+          </a:ln>
+          <a:effectLst/>
+        </p:spPr>
+        <p:style>
+          <a:lnRef idx="1">
+            <a:schemeClr val="accent1"/>
+          </a:lnRef>
+          <a:fillRef idx="3">
+            <a:schemeClr val="accent1"/>
+          </a:fillRef>
+          <a:effectRef idx="2">
+            <a:schemeClr val="accent1"/>
+          </a:effectRef>
+          <a:fontRef idx="minor">
+            <a:schemeClr val="lt1"/>
+          </a:fontRef>
+        </p:style>
+        <p:txBody>
+          <a:bodyPr rtlCol="0" anchor="ctr"/>
+          <a:lstStyle/>
+          <a:p>
+            <a:pPr algn="ctr"/>
+          </a:p>
+        </p:txBody>
+      </p:sp>
+      <p:sp>
+        <p:nvSpPr>
+          <p:cNvPr id="3" name="TextBox 2"/>
+          <p:cNvSpPr txBox="1"/>
+          <p:nvPr/>
+        </p:nvSpPr>
+        <p:spPr>
+          <a:xfrm>
+            <a:off x="502920" y="73152"/>
+            <a:ext cx="9144000" cy="320040"/>
+          </a:xfrm>
+          <a:prstGeom prst="rect">
+            <a:avLst/>
+          </a:prstGeom>
+          <a:noFill/>
+        </p:spPr>
+        <p:txBody>
+          <a:bodyPr wrap="square" anchor="t">
+            <a:spAutoFit/>
+          </a:bodyPr>
+          <a:lstStyle/>
+          <a:p>
+            <a:pPr algn="l">
+              <a:lnSpc>
+                <a:spcPct val="100000"/>
+              </a:lnSpc>
+            </a:pPr>
+            <a:r>
+              <a:rPr sz="1200" b="1" i="0">
+                <a:solidFill>
+                  <a:srgbClr val="EFF3E9"/>
+                </a:solidFill>
+                <a:latin typeface="Calibri"/>
+              </a:rPr>
+              <a:t>5. BILAN ET PERSPECTIVES</a:t>
+            </a:r>
+          </a:p>
+        </p:txBody>
+      </p:sp>
+      <p:sp>
+        <p:nvSpPr>
+          <p:cNvPr id="4" name="TextBox 3"/>
+          <p:cNvSpPr txBox="1"/>
+          <p:nvPr/>
+        </p:nvSpPr>
+        <p:spPr>
+          <a:xfrm>
+            <a:off x="502920" y="347472"/>
+            <a:ext cx="10972800" cy="640080"/>
+          </a:xfrm>
+          <a:prstGeom prst="rect">
+            <a:avLst/>
+          </a:prstGeom>
+          <a:noFill/>
+        </p:spPr>
+        <p:txBody>
+          <a:bodyPr wrap="square" anchor="t">
+            <a:spAutoFit/>
+          </a:bodyPr>
+          <a:lstStyle/>
+          <a:p>
+            <a:pPr algn="l">
+              <a:lnSpc>
+                <a:spcPct val="100000"/>
+              </a:lnSpc>
+            </a:pPr>
+            <a:r>
+              <a:rPr sz="2800" b="1" i="0">
+                <a:solidFill>
+                  <a:srgbClr val="FFFFFF"/>
+                </a:solidFill>
+                <a:latin typeface="Georgia"/>
+              </a:rPr>
+              <a:t>Perspectives d'évolution</a:t>
+            </a:r>
+          </a:p>
+        </p:txBody>
+      </p:sp>
+      <p:sp>
+        <p:nvSpPr>
+          <p:cNvPr id="5" name="Rectangle 4"/>
+          <p:cNvSpPr/>
+          <p:nvPr/>
+        </p:nvSpPr>
+        <p:spPr>
+          <a:xfrm>
+            <a:off x="0" y="1051560"/>
+            <a:ext cx="12191695" cy="38100"/>
+          </a:xfrm>
+          <a:prstGeom prst="rect">
+            <a:avLst/>
+          </a:prstGeom>
+          <a:solidFill>
+            <a:srgbClr val="2F6E62"/>
+          </a:solidFill>
+          <a:ln>
+            <a:noFill/>
+          </a:ln>
+          <a:effectLst/>
+        </p:spPr>
+        <p:style>
+          <a:lnRef idx="1">
+            <a:schemeClr val="accent1"/>
+          </a:lnRef>
+          <a:fillRef idx="3">
+            <a:schemeClr val="accent1"/>
+          </a:fillRef>
+          <a:effectRef idx="2">
+            <a:schemeClr val="accent1"/>
+          </a:effectRef>
+          <a:fontRef idx="minor">
+            <a:schemeClr val="lt1"/>
+          </a:fontRef>
+        </p:style>
+        <p:txBody>
+          <a:bodyPr rtlCol="0" anchor="ctr"/>
+          <a:lstStyle/>
+          <a:p>
+            <a:pPr algn="ctr"/>
+          </a:p>
+        </p:txBody>
+      </p:sp>
+      <p:sp>
+        <p:nvSpPr>
+          <p:cNvPr id="6" name="TextBox 5"/>
+          <p:cNvSpPr txBox="1"/>
+          <p:nvPr/>
+        </p:nvSpPr>
+        <p:spPr>
+          <a:xfrm>
+            <a:off x="640080" y="1463040"/>
+            <a:ext cx="10789920" cy="4754880"/>
+          </a:xfrm>
+          <a:prstGeom prst="rect">
+            <a:avLst/>
+          </a:prstGeom>
+          <a:noFill/>
+        </p:spPr>
+        <p:txBody>
+          <a:bodyPr wrap="square">
+            <a:spAutoFit/>
+          </a:bodyPr>
+          <a:lstStyle/>
+          <a:p>
+            <a:pPr>
+              <a:lnSpc>
+                <a:spcPct val="108000"/>
+              </a:lnSpc>
+              <a:spcAft>
+                <a:spcPts val="2000"/>
+              </a:spcAft>
+            </a:pPr>
+            <a:r>
+              <a:rPr sz="1800">
+                <a:solidFill>
+                  <a:srgbClr val="222222"/>
+                </a:solidFill>
+                <a:latin typeface="Calibri"/>
+              </a:rPr>
+              <a:t>•  Notifications par e-mail en complément de l'alerte affichée</a:t>
+            </a:r>
+          </a:p>
+          <a:p>
+            <a:pPr>
+              <a:lnSpc>
+                <a:spcPct val="108000"/>
+              </a:lnSpc>
+              <a:spcAft>
+                <a:spcPts val="2000"/>
+              </a:spcAft>
+            </a:pPr>
+            <a:r>
+              <a:rPr sz="1800">
+                <a:solidFill>
+                  <a:srgbClr val="222222"/>
+                </a:solidFill>
+                <a:latin typeface="Calibri"/>
+              </a:rPr>
+              <a:t>•  Classification par type d'appareil (fabricant + ports ouverts)</a:t>
+            </a:r>
+          </a:p>
+          <a:p>
+            <a:pPr>
+              <a:lnSpc>
+                <a:spcPct val="108000"/>
+              </a:lnSpc>
+              <a:spcAft>
+                <a:spcPts val="2000"/>
+              </a:spcAft>
+            </a:pPr>
+            <a:r>
+              <a:rPr sz="1800">
+                <a:solidFill>
+                  <a:srgbClr val="222222"/>
+                </a:solidFill>
+                <a:latin typeface="Calibri"/>
+              </a:rPr>
+              <a:t>•  Historique Git plus granulaire au fil des prochaines itérations</a:t>
+            </a:r>
+          </a:p>
+          <a:p>
+            <a:pPr>
+              <a:lnSpc>
+                <a:spcPct val="108000"/>
+              </a:lnSpc>
+              <a:spcAft>
+                <a:spcPts val="2000"/>
+              </a:spcAft>
+            </a:pPr>
+            <a:r>
+              <a:rPr sz="1800">
+                <a:solidFill>
+                  <a:srgbClr val="222222"/>
+                </a:solidFill>
+                <a:latin typeface="Calibri"/>
+              </a:rPr>
+              <a:t>•  Déploiement en production sur le serveur définitif de l'hôtel</a:t>
+            </a:r>
+          </a:p>
+        </p:txBody>
+      </p:sp>
+      <p:sp>
+        <p:nvSpPr>
+          <p:cNvPr id="7" name="TextBox 6"/>
+          <p:cNvSpPr txBox="1"/>
+          <p:nvPr/>
+        </p:nvSpPr>
+        <p:spPr>
+          <a:xfrm>
+            <a:off x="502920" y="6473952"/>
+            <a:ext cx="5486400" cy="320040"/>
+          </a:xfrm>
+          <a:prstGeom prst="rect">
+            <a:avLst/>
+          </a:prstGeom>
+          <a:noFill/>
+        </p:spPr>
+        <p:txBody>
+          <a:bodyPr wrap="square" anchor="t">
+            <a:spAutoFit/>
+          </a:bodyPr>
+          <a:lstStyle/>
+          <a:p>
+            <a:pPr algn="l">
+              <a:lnSpc>
+                <a:spcPct val="100000"/>
+              </a:lnSpc>
+            </a:pPr>
+            <a:r>
+              <a:rPr sz="900" b="0" i="0">
+                <a:solidFill>
+                  <a:srgbClr val="5A5A5A"/>
+                </a:solidFill>
+                <a:latin typeface="Calibri"/>
+              </a:rPr>
+              <a:t>NetSentry — Découverte et cartographie des équipements réseau</a:t>
+            </a:r>
+          </a:p>
+        </p:txBody>
+      </p:sp>
+      <p:sp>
+        <p:nvSpPr>
+          <p:cNvPr id="8" name="TextBox 7"/>
+          <p:cNvSpPr txBox="1"/>
+          <p:nvPr/>
+        </p:nvSpPr>
+        <p:spPr>
+          <a:xfrm>
+            <a:off x="11094415" y="6473952"/>
+            <a:ext cx="640080" cy="320040"/>
+          </a:xfrm>
+          <a:prstGeom prst="rect">
+            <a:avLst/>
+          </a:prstGeom>
+          <a:noFill/>
+        </p:spPr>
+        <p:txBody>
+          <a:bodyPr wrap="square" anchor="t">
+            <a:spAutoFit/>
+          </a:bodyPr>
+          <a:lstStyle/>
+          <a:p>
+            <a:pPr algn="r">
+              <a:lnSpc>
+                <a:spcPct val="100000"/>
+              </a:lnSpc>
+            </a:pPr>
+            <a:r>
+              <a:rPr sz="900" b="0" i="0">
+                <a:solidFill>
+                  <a:srgbClr val="5A5A5A"/>
+                </a:solidFill>
+                <a:latin typeface="Calibri"/>
+              </a:rPr>
+              <a:t>21</a:t>
+            </a:r>
+          </a:p>
+        </p:txBody>
+      </p:sp>
+    </p:spTree>
+  </p:cSld>
+  <p:clrMapOvr>
+    <a:masterClrMapping/>
+  </p:clrMapOvr>
+</p:sld>
+</file>
+
+<file path=ppt/slides/slide22.xml><?xml version="1.0" encoding="utf-8"?>
+<p:sld xmlns:a="http://schemas.openxmlformats.org/drawingml/2006/main" xmlns:p="http://schemas.openxmlformats.org/presentationml/2006/main" xmlns:r="http://schemas.openxmlformats.org/officeDocument/2006/relationships">
+  <p:cSld>
+    <p:bg>
+      <p:bgPr>
+        <a:solidFill>
+          <a:srgbClr val="FFFFFF"/>
+        </a:solidFill>
+        <a:effectLst/>
+      </p:bgPr>
+    </p:bg>
+    <p:spTree>
+      <p:nvGrpSpPr>
+        <p:cNvPr id="1" name=""/>
+        <p:cNvGrpSpPr/>
+        <p:nvPr/>
+      </p:nvGrpSpPr>
+      <p:grpSpPr/>
+      <p:sp>
+        <p:nvSpPr>
+          <p:cNvPr id="2" name="Rectangle 1"/>
+          <p:cNvSpPr/>
+          <p:nvPr/>
+        </p:nvSpPr>
+        <p:spPr>
+          <a:xfrm>
+            <a:off x="0" y="0"/>
             <a:ext cx="914400" cy="6858000"/>
           </a:xfrm>
           <a:prstGeom prst="rect">
@@ -8612,7 +8831,7 @@
         <p:spPr>
           <a:xfrm>
             <a:off x="502920" y="73152"/>
-            <a:ext cx="7315200" cy="320040"/>
+            <a:ext cx="9144000" cy="320040"/>
           </a:xfrm>
           <a:prstGeom prst="rect">
             <a:avLst/>
@@ -8637,7 +8856,7 @@
                 </a:solidFill>
                 <a:latin typeface="Calibri"/>
               </a:rPr>
-              <a:t>1. CONTEXTE ET PROBLÉMATIQUE</a:t>
+              <a:t>1. CONTEXTE GÉNÉRAL</a:t>
             </a:r>
           </a:p>
         </p:txBody>
@@ -9035,7 +9254,7 @@
         <p:spPr>
           <a:xfrm>
             <a:off x="502920" y="73152"/>
-            <a:ext cx="7315200" cy="320040"/>
+            <a:ext cx="9144000" cy="320040"/>
           </a:xfrm>
           <a:prstGeom prst="rect">
             <a:avLst/>
@@ -9060,7 +9279,7 @@
                 </a:solidFill>
                 <a:latin typeface="Calibri"/>
               </a:rPr>
-              <a:t>2. OBJECTIFS</a:t>
+              <a:t>1. CONTEXTE GÉNÉRAL</a:t>
             </a:r>
           </a:p>
         </p:txBody>
@@ -9442,7 +9661,7 @@
         <p:spPr>
           <a:xfrm>
             <a:off x="502920" y="73152"/>
-            <a:ext cx="7315200" cy="320040"/>
+            <a:ext cx="9144000" cy="320040"/>
           </a:xfrm>
           <a:prstGeom prst="rect">
             <a:avLst/>
@@ -9467,7 +9686,7 @@
                 </a:solidFill>
                 <a:latin typeface="Calibri"/>
               </a:rPr>
-              <a:t>3. ÉTUDE DE L'EXISTANT ET MÉTHODOLOGIE</a:t>
+              <a:t>1. CONTEXTE GÉNÉRAL</a:t>
             </a:r>
           </a:p>
         </p:txBody>
@@ -9940,7 +10159,7 @@
         <p:spPr>
           <a:xfrm>
             <a:off x="502920" y="73152"/>
-            <a:ext cx="7315200" cy="320040"/>
+            <a:ext cx="9144000" cy="320040"/>
           </a:xfrm>
           <a:prstGeom prst="rect">
             <a:avLst/>
@@ -9965,7 +10184,7 @@
                 </a:solidFill>
                 <a:latin typeface="Calibri"/>
               </a:rPr>
-              <a:t>3. ÉTUDE DE L'EXISTANT ET MÉTHODOLOGIE</a:t>
+              <a:t>2. ANALYSE DES BESOINS ET CONCEPTION</a:t>
             </a:r>
           </a:p>
         </p:txBody>
@@ -10562,7 +10781,7 @@
         <p:spPr>
           <a:xfrm>
             <a:off x="502920" y="73152"/>
-            <a:ext cx="7315200" cy="320040"/>
+            <a:ext cx="9144000" cy="320040"/>
           </a:xfrm>
           <a:prstGeom prst="rect">
             <a:avLst/>
@@ -10587,7 +10806,7 @@
                 </a:solidFill>
                 <a:latin typeface="Calibri"/>
               </a:rPr>
-              <a:t>5. ARCHITECTURE TECHNIQUE ET TECHNOLOGIES</a:t>
+              <a:t>2. ANALYSE DES BESOINS ET CONCEPTION</a:t>
             </a:r>
           </a:p>
         </p:txBody>
@@ -10626,7 +10845,7 @@
                 </a:solidFill>
                 <a:latin typeface="Georgia"/>
               </a:rPr>
-              <a:t>Architecture générale</a:t>
+              <a:t>Diagramme de cas d'utilisation</a:t>
             </a:r>
           </a:p>
         </p:txBody>
@@ -10677,7 +10896,7 @@
       </p:sp>
       <p:pic>
         <p:nvPicPr>
-          <p:cNvPr id="6" name="Picture 5" descr="architecture.png"/>
+          <p:cNvPr id="6" name="Picture 5" descr="use_case.png"/>
           <p:cNvPicPr>
             <a:picLocks noChangeAspect="1"/>
           </p:cNvPicPr>
@@ -10691,8 +10910,8 @@
         </p:blipFill>
         <p:spPr>
           <a:xfrm>
-            <a:off x="2423731" y="1371600"/>
-            <a:ext cx="7314057" cy="4937760"/>
+            <a:off x="4267093" y="1234440"/>
+            <a:ext cx="3353012" cy="5394960"/>
           </a:xfrm>
           <a:prstGeom prst="rect">
             <a:avLst/>
@@ -10702,6 +10921,105 @@
       <p:sp>
         <p:nvSpPr>
           <p:cNvPr id="7" name="TextBox 6"/>
+          <p:cNvSpPr txBox="1"/>
+          <p:nvPr/>
+        </p:nvSpPr>
+        <p:spPr>
+          <a:xfrm>
+            <a:off x="502920" y="1554480"/>
+            <a:ext cx="3017520" cy="4754880"/>
+          </a:xfrm>
+          <a:prstGeom prst="rect">
+            <a:avLst/>
+          </a:prstGeom>
+          <a:noFill/>
+        </p:spPr>
+        <p:txBody>
+          <a:bodyPr wrap="square">
+            <a:spAutoFit/>
+          </a:bodyPr>
+          <a:lstStyle/>
+          <a:p>
+            <a:pPr>
+              <a:lnSpc>
+                <a:spcPct val="108000"/>
+              </a:lnSpc>
+              <a:spcAft>
+                <a:spcPts val="1400"/>
+              </a:spcAft>
+            </a:pPr>
+            <a:r>
+              <a:rPr sz="1450">
+                <a:solidFill>
+                  <a:srgbClr val="222222"/>
+                </a:solidFill>
+                <a:latin typeface="Calibri"/>
+              </a:rPr>
+              <a:t>•  Un seul rôle : Administrateur IT</a:t>
+            </a:r>
+          </a:p>
+          <a:p>
+            <a:pPr>
+              <a:lnSpc>
+                <a:spcPct val="108000"/>
+              </a:lnSpc>
+              <a:spcAft>
+                <a:spcPts val="1400"/>
+              </a:spcAft>
+            </a:pPr>
+            <a:r>
+              <a:rPr sz="1450">
+                <a:solidFill>
+                  <a:srgbClr val="222222"/>
+                </a:solidFill>
+                <a:latin typeface="Calibri"/>
+              </a:rPr>
+              <a:t>•  Toutes ses actions incluent «S'authentifier»</a:t>
+            </a:r>
+          </a:p>
+          <a:p>
+            <a:pPr>
+              <a:lnSpc>
+                <a:spcPct val="108000"/>
+              </a:lnSpc>
+              <a:spcAft>
+                <a:spcPts val="1400"/>
+              </a:spcAft>
+            </a:pPr>
+            <a:r>
+              <a:rPr sz="1450">
+                <a:solidFill>
+                  <a:srgbClr val="222222"/>
+                </a:solidFill>
+                <a:latin typeface="Calibri"/>
+              </a:rPr>
+              <a:t>•  Un acteur système : le planificateur (cron)</a:t>
+            </a:r>
+          </a:p>
+          <a:p>
+            <a:pPr>
+              <a:lnSpc>
+                <a:spcPct val="108000"/>
+              </a:lnSpc>
+              <a:spcAft>
+                <a:spcPts val="1400"/>
+              </a:spcAft>
+            </a:pPr>
+            <a:r>
+              <a:rPr sz="1450">
+                <a:solidFill>
+                  <a:srgbClr val="222222"/>
+                </a:solidFill>
+                <a:latin typeface="Calibri"/>
+              </a:rPr>
+              <a:t>•  Lancer un scan (manuel ou planifié) inclut «Détecter les appareils (Nmap)»</a:t>
+            </a:r>
+          </a:p>
+        </p:txBody>
+      </p:sp>
+      <p:sp>
+        <p:nvSpPr>
+          <p:cNvPr id="8" name="TextBox 7"/>
           <p:cNvSpPr txBox="1"/>
           <p:nvPr/>
         </p:nvSpPr>
@@ -10740,7 +11058,7 @@
       </p:sp>
       <p:sp>
         <p:nvSpPr>
-          <p:cNvPr id="8" name="TextBox 7"/>
+          <p:cNvPr id="9" name="TextBox 8"/>
           <p:cNvSpPr txBox="1"/>
           <p:nvPr/>
         </p:nvSpPr>
@@ -10856,7 +11174,7 @@
         <p:spPr>
           <a:xfrm>
             <a:off x="502920" y="73152"/>
-            <a:ext cx="7315200" cy="320040"/>
+            <a:ext cx="9144000" cy="320040"/>
           </a:xfrm>
           <a:prstGeom prst="rect">
             <a:avLst/>
@@ -10881,7 +11199,7 @@
                 </a:solidFill>
                 <a:latin typeface="Calibri"/>
               </a:rPr>
-              <a:t>4. ANALYSE ET CONCEPTION (UML)</a:t>
+              <a:t>2. ANALYSE DES BESOINS ET CONCEPTION</a:t>
             </a:r>
           </a:p>
         </p:txBody>
@@ -10920,7 +11238,7 @@
                 </a:solidFill>
                 <a:latin typeface="Georgia"/>
               </a:rPr>
-              <a:t>Diagramme de cas d'utilisation</a:t>
+              <a:t>Diagramme de séquence</a:t>
             </a:r>
           </a:p>
         </p:txBody>
@@ -10971,7 +11289,7 @@
       </p:sp>
       <p:pic>
         <p:nvPicPr>
-          <p:cNvPr id="6" name="Picture 5" descr="use_case.png"/>
+          <p:cNvPr id="6" name="Picture 5" descr="diagramme_sequence.png"/>
           <p:cNvPicPr>
             <a:picLocks noChangeAspect="1"/>
           </p:cNvPicPr>
@@ -10985,8 +11303,8 @@
         </p:blipFill>
         <p:spPr>
           <a:xfrm>
-            <a:off x="4267093" y="1234440"/>
-            <a:ext cx="3353012" cy="5394960"/>
+            <a:off x="3323802" y="1234440"/>
+            <a:ext cx="5513915" cy="5394960"/>
           </a:xfrm>
           <a:prstGeom prst="rect">
             <a:avLst/>
@@ -10996,105 +11314,6 @@
       <p:sp>
         <p:nvSpPr>
           <p:cNvPr id="7" name="TextBox 6"/>
-          <p:cNvSpPr txBox="1"/>
-          <p:nvPr/>
-        </p:nvSpPr>
-        <p:spPr>
-          <a:xfrm>
-            <a:off x="502920" y="1554480"/>
-            <a:ext cx="3017520" cy="4754880"/>
-          </a:xfrm>
-          <a:prstGeom prst="rect">
-            <a:avLst/>
-          </a:prstGeom>
-          <a:noFill/>
-        </p:spPr>
-        <p:txBody>
-          <a:bodyPr wrap="square">
-            <a:spAutoFit/>
-          </a:bodyPr>
-          <a:lstStyle/>
-          <a:p>
-            <a:pPr>
-              <a:lnSpc>
-                <a:spcPct val="108000"/>
-              </a:lnSpc>
-              <a:spcAft>
-                <a:spcPts val="1400"/>
-              </a:spcAft>
-            </a:pPr>
-            <a:r>
-              <a:rPr sz="1450">
-                <a:solidFill>
-                  <a:srgbClr val="222222"/>
-                </a:solidFill>
-                <a:latin typeface="Calibri"/>
-              </a:rPr>
-              <a:t>•  Un seul rôle : Administrateur IT</a:t>
-            </a:r>
-          </a:p>
-          <a:p>
-            <a:pPr>
-              <a:lnSpc>
-                <a:spcPct val="108000"/>
-              </a:lnSpc>
-              <a:spcAft>
-                <a:spcPts val="1400"/>
-              </a:spcAft>
-            </a:pPr>
-            <a:r>
-              <a:rPr sz="1450">
-                <a:solidFill>
-                  <a:srgbClr val="222222"/>
-                </a:solidFill>
-                <a:latin typeface="Calibri"/>
-              </a:rPr>
-              <a:t>•  Toutes ses actions incluent «S'authentifier»</a:t>
-            </a:r>
-          </a:p>
-          <a:p>
-            <a:pPr>
-              <a:lnSpc>
-                <a:spcPct val="108000"/>
-              </a:lnSpc>
-              <a:spcAft>
-                <a:spcPts val="1400"/>
-              </a:spcAft>
-            </a:pPr>
-            <a:r>
-              <a:rPr sz="1450">
-                <a:solidFill>
-                  <a:srgbClr val="222222"/>
-                </a:solidFill>
-                <a:latin typeface="Calibri"/>
-              </a:rPr>
-              <a:t>•  Un acteur système : le planificateur (cron)</a:t>
-            </a:r>
-          </a:p>
-          <a:p>
-            <a:pPr>
-              <a:lnSpc>
-                <a:spcPct val="108000"/>
-              </a:lnSpc>
-              <a:spcAft>
-                <a:spcPts val="1400"/>
-              </a:spcAft>
-            </a:pPr>
-            <a:r>
-              <a:rPr sz="1450">
-                <a:solidFill>
-                  <a:srgbClr val="222222"/>
-                </a:solidFill>
-                <a:latin typeface="Calibri"/>
-              </a:rPr>
-              <a:t>•  Lancer un scan (manuel ou planifié) inclut «Détecter les appareils (Nmap)»</a:t>
-            </a:r>
-          </a:p>
-        </p:txBody>
-      </p:sp>
-      <p:sp>
-        <p:nvSpPr>
-          <p:cNvPr id="8" name="TextBox 7"/>
           <p:cNvSpPr txBox="1"/>
           <p:nvPr/>
         </p:nvSpPr>
@@ -11133,7 +11352,7 @@
       </p:sp>
       <p:sp>
         <p:nvSpPr>
-          <p:cNvPr id="9" name="TextBox 8"/>
+          <p:cNvPr id="8" name="TextBox 7"/>
           <p:cNvSpPr txBox="1"/>
           <p:nvPr/>
         </p:nvSpPr>
@@ -11249,7 +11468,7 @@
         <p:spPr>
           <a:xfrm>
             <a:off x="502920" y="73152"/>
-            <a:ext cx="7315200" cy="320040"/>
+            <a:ext cx="9144000" cy="320040"/>
           </a:xfrm>
           <a:prstGeom prst="rect">
             <a:avLst/>
@@ -11274,7 +11493,7 @@
                 </a:solidFill>
                 <a:latin typeface="Calibri"/>
               </a:rPr>
-              <a:t>4. ANALYSE ET CONCEPTION (UML)</a:t>
+              <a:t>2. ANALYSE DES BESOINS ET CONCEPTION</a:t>
             </a:r>
           </a:p>
         </p:txBody>

</xml_diff>